<commit_message>
Simplifica el contenido de la propuesta de PobreVermut
- Las fases dejan de anclarse a meses; solo queda el canal de cada una.
- Sale el listado de lo que no se incluye.
- El honorario queda como monto líquido a secas, sin desglose tributario.
- El variable sobre ventas se reemplaza por un primer ciclo de tres meses
  con revisión de resultados al cierre.
- El slide de requisitos se reemplaza por un cierre de invitación.

Co-Authored-By: Claude Opus 5 <noreply@anthropic.com>
Claude-Session: https://claude.ai/code/session_01TbbPRaX9MW6Lcxus2ycV3h
</commit_message>
<xml_diff>
--- a/propuestas/pobrevermut/PobreVermut - Propuesta Campanas 2026.pptx
+++ b/propuestas/pobrevermut/PobreVermut - Propuesta Campanas 2026.pptx
@@ -1682,7 +1682,7 @@
               <a:buNone/>
             </a:pPr>
             <a:r>
-              <a:rPr lang="en-US" sz="1050" b="1" spc="150" kern="0" dirty="0">
+              <a:rPr lang="en-US" sz="1050" b="1" spc="250" kern="0" dirty="0">
                 <a:solidFill>
                   <a:srgbClr val="8A807A"/>
                 </a:solidFill>
@@ -1690,7 +1690,7 @@
                 <a:ea typeface="Arial" pitchFamily="34" charset="-122"/>
                 <a:cs typeface="Arial" pitchFamily="34" charset="-120"/>
               </a:rPr>
-              <a:t>MES 1 – 2  ·  META</a:t>
+              <a:t>META</a:t>
             </a:r>
             <a:endParaRPr lang="en-US" sz="1050" dirty="0"/>
           </a:p>
@@ -1864,7 +1864,7 @@
               <a:buNone/>
             </a:pPr>
             <a:r>
-              <a:rPr lang="en-US" sz="1050" b="1" spc="150" kern="0" dirty="0">
+              <a:rPr lang="en-US" sz="1050" b="1" spc="250" kern="0" dirty="0">
                 <a:solidFill>
                   <a:srgbClr val="8A807A"/>
                 </a:solidFill>
@@ -1872,7 +1872,7 @@
                 <a:ea typeface="Arial" pitchFamily="34" charset="-122"/>
                 <a:cs typeface="Arial" pitchFamily="34" charset="-120"/>
               </a:rPr>
-              <a:t>MES 3 – 4  ·  META</a:t>
+              <a:t>META</a:t>
             </a:r>
             <a:endParaRPr lang="en-US" sz="1050" dirty="0"/>
           </a:p>
@@ -2046,7 +2046,7 @@
               <a:buNone/>
             </a:pPr>
             <a:r>
-              <a:rPr lang="en-US" sz="1050" b="1" spc="150" kern="0" dirty="0">
+              <a:rPr lang="en-US" sz="1050" b="1" spc="250" kern="0" dirty="0">
                 <a:solidFill>
                   <a:srgbClr val="8A807A"/>
                 </a:solidFill>
@@ -2054,7 +2054,7 @@
                 <a:ea typeface="Arial" pitchFamily="34" charset="-122"/>
                 <a:cs typeface="Arial" pitchFamily="34" charset="-120"/>
               </a:rPr>
-              <a:t>MES 5 +  ·  GOOGLE</a:t>
+              <a:t>GOOGLE</a:t>
             </a:r>
             <a:endParaRPr lang="en-US" sz="1050" dirty="0"/>
           </a:p>
@@ -2282,8 +2282,8 @@
         </p:nvSpPr>
         <p:spPr>
           <a:xfrm>
-            <a:off x="822960" y="2514600"/>
-            <a:ext cx="566928" cy="475488"/>
+            <a:off x="822960" y="2578608"/>
+            <a:ext cx="658368" cy="530352"/>
           </a:xfrm>
           <a:prstGeom prst="rect">
             <a:avLst/>
@@ -2299,7 +2299,7 @@
               <a:buNone/>
             </a:pPr>
             <a:r>
-              <a:rPr lang="en-US" sz="1400" b="1" dirty="0">
+              <a:rPr lang="en-US" sz="1600" b="1" dirty="0">
                 <a:solidFill>
                   <a:srgbClr val="EF5B25"/>
                 </a:solidFill>
@@ -2309,7 +2309,7 @@
               </a:rPr>
               <a:t>01</a:t>
             </a:r>
-            <a:endParaRPr lang="en-US" sz="1400" dirty="0"/>
+            <a:endParaRPr lang="en-US" sz="1600" dirty="0"/>
           </a:p>
         </p:txBody>
       </p:sp>
@@ -2321,8 +2321,8 @@
         </p:nvSpPr>
         <p:spPr>
           <a:xfrm>
-            <a:off x="1463040" y="2514600"/>
-            <a:ext cx="5760720" cy="475488"/>
+            <a:off x="1664208" y="2578608"/>
+            <a:ext cx="9704527" cy="530352"/>
           </a:xfrm>
           <a:prstGeom prst="rect">
             <a:avLst/>
@@ -2338,7 +2338,7 @@
               <a:buNone/>
             </a:pPr>
             <a:r>
-              <a:rPr lang="en-US" sz="1800" dirty="0">
+              <a:rPr lang="en-US" sz="2100" dirty="0">
                 <a:solidFill>
                   <a:srgbClr val="F2EEE9"/>
                 </a:solidFill>
@@ -2348,7 +2348,7 @@
               </a:rPr>
               <a:t>El plan de medios del mes</a:t>
             </a:r>
-            <a:endParaRPr lang="en-US" sz="1800" dirty="0"/>
+            <a:endParaRPr lang="en-US" sz="2100" dirty="0"/>
           </a:p>
         </p:txBody>
       </p:sp>
@@ -2360,8 +2360,8 @@
         </p:nvSpPr>
         <p:spPr>
           <a:xfrm>
-            <a:off x="822960" y="3209544"/>
-            <a:ext cx="566928" cy="475488"/>
+            <a:off x="822960" y="3310128"/>
+            <a:ext cx="658368" cy="530352"/>
           </a:xfrm>
           <a:prstGeom prst="rect">
             <a:avLst/>
@@ -2377,7 +2377,7 @@
               <a:buNone/>
             </a:pPr>
             <a:r>
-              <a:rPr lang="en-US" sz="1400" b="1" dirty="0">
+              <a:rPr lang="en-US" sz="1600" b="1" dirty="0">
                 <a:solidFill>
                   <a:srgbClr val="EF5B25"/>
                 </a:solidFill>
@@ -2387,7 +2387,7 @@
               </a:rPr>
               <a:t>02</a:t>
             </a:r>
-            <a:endParaRPr lang="en-US" sz="1400" dirty="0"/>
+            <a:endParaRPr lang="en-US" sz="1600" dirty="0"/>
           </a:p>
         </p:txBody>
       </p:sp>
@@ -2399,8 +2399,8 @@
         </p:nvSpPr>
         <p:spPr>
           <a:xfrm>
-            <a:off x="1463040" y="3209544"/>
-            <a:ext cx="5760720" cy="475488"/>
+            <a:off x="1664208" y="3310128"/>
+            <a:ext cx="9704527" cy="530352"/>
           </a:xfrm>
           <a:prstGeom prst="rect">
             <a:avLst/>
@@ -2416,7 +2416,7 @@
               <a:buNone/>
             </a:pPr>
             <a:r>
-              <a:rPr lang="en-US" sz="1800" dirty="0">
+              <a:rPr lang="en-US" sz="2100" dirty="0">
                 <a:solidFill>
                   <a:srgbClr val="F2EEE9"/>
                 </a:solidFill>
@@ -2426,7 +2426,7 @@
               </a:rPr>
               <a:t>El requerimiento de creativos al equipo creativo</a:t>
             </a:r>
-            <a:endParaRPr lang="en-US" sz="1800" dirty="0"/>
+            <a:endParaRPr lang="en-US" sz="2100" dirty="0"/>
           </a:p>
         </p:txBody>
       </p:sp>
@@ -2438,8 +2438,8 @@
         </p:nvSpPr>
         <p:spPr>
           <a:xfrm>
-            <a:off x="822960" y="3904488"/>
-            <a:ext cx="566928" cy="475488"/>
+            <a:off x="822960" y="4041648"/>
+            <a:ext cx="658368" cy="530352"/>
           </a:xfrm>
           <a:prstGeom prst="rect">
             <a:avLst/>
@@ -2455,7 +2455,7 @@
               <a:buNone/>
             </a:pPr>
             <a:r>
-              <a:rPr lang="en-US" sz="1400" b="1" dirty="0">
+              <a:rPr lang="en-US" sz="1600" b="1" dirty="0">
                 <a:solidFill>
                   <a:srgbClr val="EF5B25"/>
                 </a:solidFill>
@@ -2465,7 +2465,7 @@
               </a:rPr>
               <a:t>03</a:t>
             </a:r>
-            <a:endParaRPr lang="en-US" sz="1400" dirty="0"/>
+            <a:endParaRPr lang="en-US" sz="1600" dirty="0"/>
           </a:p>
         </p:txBody>
       </p:sp>
@@ -2477,8 +2477,8 @@
         </p:nvSpPr>
         <p:spPr>
           <a:xfrm>
-            <a:off x="1463040" y="3904488"/>
-            <a:ext cx="5760720" cy="475488"/>
+            <a:off x="1664208" y="4041648"/>
+            <a:ext cx="9704527" cy="530352"/>
           </a:xfrm>
           <a:prstGeom prst="rect">
             <a:avLst/>
@@ -2494,7 +2494,7 @@
               <a:buNone/>
             </a:pPr>
             <a:r>
-              <a:rPr lang="en-US" sz="1800" dirty="0">
+              <a:rPr lang="en-US" sz="2100" dirty="0">
                 <a:solidFill>
                   <a:srgbClr val="F2EEE9"/>
                 </a:solidFill>
@@ -2504,7 +2504,7 @@
               </a:rPr>
               <a:t>Configuración de campañas, píxel y catálogo</a:t>
             </a:r>
-            <a:endParaRPr lang="en-US" sz="1800" dirty="0"/>
+            <a:endParaRPr lang="en-US" sz="2100" dirty="0"/>
           </a:p>
         </p:txBody>
       </p:sp>
@@ -2516,8 +2516,8 @@
         </p:nvSpPr>
         <p:spPr>
           <a:xfrm>
-            <a:off x="822960" y="4599432"/>
-            <a:ext cx="566928" cy="475488"/>
+            <a:off x="822960" y="4773168"/>
+            <a:ext cx="658368" cy="530352"/>
           </a:xfrm>
           <a:prstGeom prst="rect">
             <a:avLst/>
@@ -2533,7 +2533,7 @@
               <a:buNone/>
             </a:pPr>
             <a:r>
-              <a:rPr lang="en-US" sz="1400" b="1" dirty="0">
+              <a:rPr lang="en-US" sz="1600" b="1" dirty="0">
                 <a:solidFill>
                   <a:srgbClr val="EF5B25"/>
                 </a:solidFill>
@@ -2543,7 +2543,7 @@
               </a:rPr>
               <a:t>04</a:t>
             </a:r>
-            <a:endParaRPr lang="en-US" sz="1400" dirty="0"/>
+            <a:endParaRPr lang="en-US" sz="1600" dirty="0"/>
           </a:p>
         </p:txBody>
       </p:sp>
@@ -2555,8 +2555,8 @@
         </p:nvSpPr>
         <p:spPr>
           <a:xfrm>
-            <a:off x="1463040" y="4599432"/>
-            <a:ext cx="5760720" cy="475488"/>
+            <a:off x="1664208" y="4773168"/>
+            <a:ext cx="9704527" cy="530352"/>
           </a:xfrm>
           <a:prstGeom prst="rect">
             <a:avLst/>
@@ -2572,7 +2572,7 @@
               <a:buNone/>
             </a:pPr>
             <a:r>
-              <a:rPr lang="en-US" sz="1800" dirty="0">
+              <a:rPr lang="en-US" sz="2100" dirty="0">
                 <a:solidFill>
                   <a:srgbClr val="F2EEE9"/>
                 </a:solidFill>
@@ -2582,7 +2582,7 @@
               </a:rPr>
               <a:t>Optimización durante todo el mes</a:t>
             </a:r>
-            <a:endParaRPr lang="en-US" sz="1800" dirty="0"/>
+            <a:endParaRPr lang="en-US" sz="2100" dirty="0"/>
           </a:p>
         </p:txBody>
       </p:sp>
@@ -2594,8 +2594,8 @@
         </p:nvSpPr>
         <p:spPr>
           <a:xfrm>
-            <a:off x="822960" y="5294376"/>
-            <a:ext cx="566928" cy="475488"/>
+            <a:off x="822960" y="5504688"/>
+            <a:ext cx="658368" cy="530352"/>
           </a:xfrm>
           <a:prstGeom prst="rect">
             <a:avLst/>
@@ -2611,7 +2611,7 @@
               <a:buNone/>
             </a:pPr>
             <a:r>
-              <a:rPr lang="en-US" sz="1400" b="1" dirty="0">
+              <a:rPr lang="en-US" sz="1600" b="1" dirty="0">
                 <a:solidFill>
                   <a:srgbClr val="EF5B25"/>
                 </a:solidFill>
@@ -2621,7 +2621,7 @@
               </a:rPr>
               <a:t>05</a:t>
             </a:r>
-            <a:endParaRPr lang="en-US" sz="1400" dirty="0"/>
+            <a:endParaRPr lang="en-US" sz="1600" dirty="0"/>
           </a:p>
         </p:txBody>
       </p:sp>
@@ -2633,8 +2633,8 @@
         </p:nvSpPr>
         <p:spPr>
           <a:xfrm>
-            <a:off x="1463040" y="5294376"/>
-            <a:ext cx="5760720" cy="475488"/>
+            <a:off x="1664208" y="5504688"/>
+            <a:ext cx="9704527" cy="530352"/>
           </a:xfrm>
           <a:prstGeom prst="rect">
             <a:avLst/>
@@ -2650,7 +2650,7 @@
               <a:buNone/>
             </a:pPr>
             <a:r>
-              <a:rPr lang="en-US" sz="1800" dirty="0">
+              <a:rPr lang="en-US" sz="2100" dirty="0">
                 <a:solidFill>
                   <a:srgbClr val="F2EEE9"/>
                 </a:solidFill>
@@ -2660,223 +2660,7 @@
               </a:rPr>
               <a:t>Reporte mensual con ventas, no con likes</a:t>
             </a:r>
-            <a:endParaRPr lang="en-US" sz="1800" dirty="0"/>
-          </a:p>
-        </p:txBody>
-      </p:sp>
-      <p:sp>
-        <p:nvSpPr>
-          <p:cNvPr id="14" name="Text 12"/>
-          <p:cNvSpPr/>
-          <p:nvPr/>
-        </p:nvSpPr>
-        <p:spPr>
-          <a:xfrm>
-            <a:off x="7589520" y="2542032"/>
-            <a:ext cx="3779215" cy="274320"/>
-          </a:xfrm>
-          <a:prstGeom prst="rect">
-            <a:avLst/>
-          </a:prstGeom>
-          <a:noFill/>
-          <a:ln/>
-        </p:spPr>
-        <p:txBody>
-          <a:bodyPr wrap="square" lIns="0" tIns="0" rIns="0" bIns="0" rtlCol="0" anchor="ctr"/>
-          <a:lstStyle/>
-          <a:p>
-            <a:pPr indent="0" marL="0">
-              <a:buNone/>
-            </a:pPr>
-            <a:r>
-              <a:rPr lang="en-US" sz="1050" b="1" spc="250" kern="0" dirty="0">
-                <a:solidFill>
-                  <a:srgbClr val="EF5B25"/>
-                </a:solidFill>
-                <a:latin typeface="Arial" pitchFamily="34" charset="0"/>
-                <a:ea typeface="Arial" pitchFamily="34" charset="-122"/>
-                <a:cs typeface="Arial" pitchFamily="34" charset="-120"/>
-              </a:rPr>
-              <a:t>NO INCLUYE</a:t>
-            </a:r>
-            <a:endParaRPr lang="en-US" sz="1050" dirty="0"/>
-          </a:p>
-        </p:txBody>
-      </p:sp>
-      <p:sp>
-        <p:nvSpPr>
-          <p:cNvPr id="15" name="Shape 13"/>
-          <p:cNvSpPr/>
-          <p:nvPr/>
-        </p:nvSpPr>
-        <p:spPr>
-          <a:xfrm>
-            <a:off x="7589520" y="3236976"/>
-            <a:ext cx="128016" cy="128016"/>
-          </a:xfrm>
-          <a:prstGeom prst="ellipse">
-            <a:avLst/>
-          </a:prstGeom>
-          <a:solidFill>
-            <a:srgbClr val="8A807A"/>
-          </a:solidFill>
-          <a:ln/>
-        </p:spPr>
-      </p:sp>
-      <p:sp>
-        <p:nvSpPr>
-          <p:cNvPr id="16" name="Text 14"/>
-          <p:cNvSpPr/>
-          <p:nvPr/>
-        </p:nvSpPr>
-        <p:spPr>
-          <a:xfrm>
-            <a:off x="7955280" y="3063240"/>
-            <a:ext cx="3413455" cy="457200"/>
-          </a:xfrm>
-          <a:prstGeom prst="rect">
-            <a:avLst/>
-          </a:prstGeom>
-          <a:noFill/>
-          <a:ln/>
-        </p:spPr>
-        <p:txBody>
-          <a:bodyPr wrap="square" lIns="0" tIns="0" rIns="0" bIns="0" rtlCol="0" anchor="ctr"/>
-          <a:lstStyle/>
-          <a:p>
-            <a:pPr indent="0" marL="0">
-              <a:buNone/>
-            </a:pPr>
-            <a:r>
-              <a:rPr lang="en-US" sz="1600" dirty="0">
-                <a:solidFill>
-                  <a:srgbClr val="8A807A"/>
-                </a:solidFill>
-                <a:latin typeface="Calibri" pitchFamily="34" charset="0"/>
-                <a:ea typeface="Calibri" pitchFamily="34" charset="-122"/>
-                <a:cs typeface="Calibri" pitchFamily="34" charset="-120"/>
-              </a:rPr>
-              <a:t>Producción de creativos</a:t>
-            </a:r>
-            <a:endParaRPr lang="en-US" sz="1600" dirty="0"/>
-          </a:p>
-        </p:txBody>
-      </p:sp>
-      <p:sp>
-        <p:nvSpPr>
-          <p:cNvPr id="17" name="Shape 15"/>
-          <p:cNvSpPr/>
-          <p:nvPr/>
-        </p:nvSpPr>
-        <p:spPr>
-          <a:xfrm>
-            <a:off x="7589520" y="3803904"/>
-            <a:ext cx="128016" cy="128016"/>
-          </a:xfrm>
-          <a:prstGeom prst="ellipse">
-            <a:avLst/>
-          </a:prstGeom>
-          <a:solidFill>
-            <a:srgbClr val="8A807A"/>
-          </a:solidFill>
-          <a:ln/>
-        </p:spPr>
-      </p:sp>
-      <p:sp>
-        <p:nvSpPr>
-          <p:cNvPr id="18" name="Text 16"/>
-          <p:cNvSpPr/>
-          <p:nvPr/>
-        </p:nvSpPr>
-        <p:spPr>
-          <a:xfrm>
-            <a:off x="7955280" y="3630168"/>
-            <a:ext cx="3413455" cy="457200"/>
-          </a:xfrm>
-          <a:prstGeom prst="rect">
-            <a:avLst/>
-          </a:prstGeom>
-          <a:noFill/>
-          <a:ln/>
-        </p:spPr>
-        <p:txBody>
-          <a:bodyPr wrap="square" lIns="0" tIns="0" rIns="0" bIns="0" rtlCol="0" anchor="ctr"/>
-          <a:lstStyle/>
-          <a:p>
-            <a:pPr indent="0" marL="0">
-              <a:buNone/>
-            </a:pPr>
-            <a:r>
-              <a:rPr lang="en-US" sz="1600" dirty="0">
-                <a:solidFill>
-                  <a:srgbClr val="8A807A"/>
-                </a:solidFill>
-                <a:latin typeface="Calibri" pitchFamily="34" charset="0"/>
-                <a:ea typeface="Calibri" pitchFamily="34" charset="-122"/>
-                <a:cs typeface="Calibri" pitchFamily="34" charset="-120"/>
-              </a:rPr>
-              <a:t>Community management</a:t>
-            </a:r>
-            <a:endParaRPr lang="en-US" sz="1600" dirty="0"/>
-          </a:p>
-        </p:txBody>
-      </p:sp>
-      <p:sp>
-        <p:nvSpPr>
-          <p:cNvPr id="19" name="Shape 17"/>
-          <p:cNvSpPr/>
-          <p:nvPr/>
-        </p:nvSpPr>
-        <p:spPr>
-          <a:xfrm>
-            <a:off x="7589520" y="4370832"/>
-            <a:ext cx="128016" cy="128016"/>
-          </a:xfrm>
-          <a:prstGeom prst="ellipse">
-            <a:avLst/>
-          </a:prstGeom>
-          <a:solidFill>
-            <a:srgbClr val="8A807A"/>
-          </a:solidFill>
-          <a:ln/>
-        </p:spPr>
-      </p:sp>
-      <p:sp>
-        <p:nvSpPr>
-          <p:cNvPr id="20" name="Text 18"/>
-          <p:cNvSpPr/>
-          <p:nvPr/>
-        </p:nvSpPr>
-        <p:spPr>
-          <a:xfrm>
-            <a:off x="7955280" y="4197096"/>
-            <a:ext cx="3413455" cy="457200"/>
-          </a:xfrm>
-          <a:prstGeom prst="rect">
-            <a:avLst/>
-          </a:prstGeom>
-          <a:noFill/>
-          <a:ln/>
-        </p:spPr>
-        <p:txBody>
-          <a:bodyPr wrap="square" lIns="0" tIns="0" rIns="0" bIns="0" rtlCol="0" anchor="ctr"/>
-          <a:lstStyle/>
-          <a:p>
-            <a:pPr indent="0" marL="0">
-              <a:buNone/>
-            </a:pPr>
-            <a:r>
-              <a:rPr lang="en-US" sz="1600" dirty="0">
-                <a:solidFill>
-                  <a:srgbClr val="8A807A"/>
-                </a:solidFill>
-                <a:latin typeface="Calibri" pitchFamily="34" charset="0"/>
-                <a:ea typeface="Calibri" pitchFamily="34" charset="-122"/>
-                <a:cs typeface="Calibri" pitchFamily="34" charset="-120"/>
-              </a:rPr>
-              <a:t>La inversión en pauta</a:t>
-            </a:r>
-            <a:endParaRPr lang="en-US" sz="1600" dirty="0"/>
+            <a:endParaRPr lang="en-US" sz="2100" dirty="0"/>
           </a:p>
         </p:txBody>
       </p:sp>
@@ -2959,8 +2743,8 @@
         </p:nvSpPr>
         <p:spPr>
           <a:xfrm>
-            <a:off x="822960" y="1645920"/>
-            <a:ext cx="5852160" cy="1417320"/>
+            <a:off x="822960" y="1600200"/>
+            <a:ext cx="8686800" cy="1600200"/>
           </a:xfrm>
           <a:prstGeom prst="rect">
             <a:avLst/>
@@ -2976,7 +2760,7 @@
               <a:buNone/>
             </a:pPr>
             <a:r>
-              <a:rPr lang="en-US" sz="7800" b="1" dirty="0">
+              <a:rPr lang="en-US" sz="9600" b="1" dirty="0">
                 <a:solidFill>
                   <a:srgbClr val="140C07"/>
                 </a:solidFill>
@@ -2986,7 +2770,7 @@
               </a:rPr>
               <a:t>$350.000</a:t>
             </a:r>
-            <a:endParaRPr lang="en-US" sz="7800" dirty="0"/>
+            <a:endParaRPr lang="en-US" sz="9600" dirty="0"/>
           </a:p>
         </p:txBody>
       </p:sp>
@@ -2998,8 +2782,8 @@
         </p:nvSpPr>
         <p:spPr>
           <a:xfrm>
-            <a:off x="822960" y="3090672"/>
-            <a:ext cx="5852160" cy="384048"/>
+            <a:off x="822960" y="3310128"/>
+            <a:ext cx="7315200" cy="457200"/>
           </a:xfrm>
           <a:prstGeom prst="rect">
             <a:avLst/>
@@ -3015,7 +2799,7 @@
               <a:buNone/>
             </a:pPr>
             <a:r>
-              <a:rPr lang="en-US" sz="2000" dirty="0">
+              <a:rPr lang="en-US" sz="2400" dirty="0">
                 <a:solidFill>
                   <a:srgbClr val="140C07"/>
                 </a:solidFill>
@@ -3025,7 +2809,7 @@
               </a:rPr>
               <a:t>líquidos al mes</a:t>
             </a:r>
-            <a:endParaRPr lang="en-US" sz="2000" dirty="0"/>
+            <a:endParaRPr lang="en-US" sz="2400" dirty="0"/>
           </a:p>
         </p:txBody>
       </p:sp>
@@ -3037,281 +2821,8 @@
         </p:nvSpPr>
         <p:spPr>
           <a:xfrm>
-            <a:off x="822960" y="4069080"/>
-            <a:ext cx="3108960" cy="384048"/>
-          </a:xfrm>
-          <a:prstGeom prst="rect">
-            <a:avLst/>
-          </a:prstGeom>
-          <a:noFill/>
-          <a:ln/>
-        </p:spPr>
-        <p:txBody>
-          <a:bodyPr wrap="square" lIns="0" tIns="0" rIns="0" bIns="0" rtlCol="0" anchor="ctr"/>
-          <a:lstStyle/>
-          <a:p>
-            <a:pPr indent="0" marL="0">
-              <a:buNone/>
-            </a:pPr>
-            <a:r>
-              <a:rPr lang="en-US" sz="1400" dirty="0">
-                <a:solidFill>
-                  <a:srgbClr val="140C07"/>
-                </a:solidFill>
-                <a:latin typeface="Calibri" pitchFamily="34" charset="0"/>
-                <a:ea typeface="Calibri" pitchFamily="34" charset="-122"/>
-                <a:cs typeface="Calibri" pitchFamily="34" charset="-120"/>
-              </a:rPr>
-              <a:t>Honorario bruto</a:t>
-            </a:r>
-            <a:endParaRPr lang="en-US" sz="1400" dirty="0"/>
-          </a:p>
-        </p:txBody>
-      </p:sp>
-      <p:sp>
-        <p:nvSpPr>
-          <p:cNvPr id="6" name="Text 4"/>
-          <p:cNvSpPr/>
-          <p:nvPr/>
-        </p:nvSpPr>
-        <p:spPr>
-          <a:xfrm>
-            <a:off x="3931920" y="4069080"/>
-            <a:ext cx="2011680" cy="384048"/>
-          </a:xfrm>
-          <a:prstGeom prst="rect">
-            <a:avLst/>
-          </a:prstGeom>
-          <a:noFill/>
-          <a:ln/>
-        </p:spPr>
-        <p:txBody>
-          <a:bodyPr wrap="square" lIns="0" tIns="0" rIns="0" bIns="0" rtlCol="0" anchor="ctr"/>
-          <a:lstStyle/>
-          <a:p>
-            <a:pPr algn="r" indent="0" marL="0">
-              <a:buNone/>
-            </a:pPr>
-            <a:r>
-              <a:rPr lang="en-US" sz="1400" dirty="0">
-                <a:solidFill>
-                  <a:srgbClr val="140C07"/>
-                </a:solidFill>
-                <a:latin typeface="Calibri" pitchFamily="34" charset="0"/>
-                <a:ea typeface="Calibri" pitchFamily="34" charset="-122"/>
-                <a:cs typeface="Calibri" pitchFamily="34" charset="-120"/>
-              </a:rPr>
-              <a:t>$412.979</a:t>
-            </a:r>
-            <a:endParaRPr lang="en-US" sz="1400" dirty="0"/>
-          </a:p>
-        </p:txBody>
-      </p:sp>
-      <p:sp>
-        <p:nvSpPr>
-          <p:cNvPr id="7" name="Text 5"/>
-          <p:cNvSpPr/>
-          <p:nvPr/>
-        </p:nvSpPr>
-        <p:spPr>
-          <a:xfrm>
-            <a:off x="822960" y="4544568"/>
-            <a:ext cx="3108960" cy="384048"/>
-          </a:xfrm>
-          <a:prstGeom prst="rect">
-            <a:avLst/>
-          </a:prstGeom>
-          <a:noFill/>
-          <a:ln/>
-        </p:spPr>
-        <p:txBody>
-          <a:bodyPr wrap="square" lIns="0" tIns="0" rIns="0" bIns="0" rtlCol="0" anchor="ctr"/>
-          <a:lstStyle/>
-          <a:p>
-            <a:pPr indent="0" marL="0">
-              <a:buNone/>
-            </a:pPr>
-            <a:r>
-              <a:rPr lang="en-US" sz="1400" dirty="0">
-                <a:solidFill>
-                  <a:srgbClr val="140C07"/>
-                </a:solidFill>
-                <a:latin typeface="Calibri" pitchFamily="34" charset="0"/>
-                <a:ea typeface="Calibri" pitchFamily="34" charset="-122"/>
-                <a:cs typeface="Calibri" pitchFamily="34" charset="-120"/>
-              </a:rPr>
-              <a:t>Retención 15,25%</a:t>
-            </a:r>
-            <a:endParaRPr lang="en-US" sz="1400" dirty="0"/>
-          </a:p>
-        </p:txBody>
-      </p:sp>
-      <p:sp>
-        <p:nvSpPr>
-          <p:cNvPr id="8" name="Text 6"/>
-          <p:cNvSpPr/>
-          <p:nvPr/>
-        </p:nvSpPr>
-        <p:spPr>
-          <a:xfrm>
-            <a:off x="3931920" y="4544568"/>
-            <a:ext cx="2011680" cy="384048"/>
-          </a:xfrm>
-          <a:prstGeom prst="rect">
-            <a:avLst/>
-          </a:prstGeom>
-          <a:noFill/>
-          <a:ln/>
-        </p:spPr>
-        <p:txBody>
-          <a:bodyPr wrap="square" lIns="0" tIns="0" rIns="0" bIns="0" rtlCol="0" anchor="ctr"/>
-          <a:lstStyle/>
-          <a:p>
-            <a:pPr algn="r" indent="0" marL="0">
-              <a:buNone/>
-            </a:pPr>
-            <a:r>
-              <a:rPr lang="en-US" sz="1400" dirty="0">
-                <a:solidFill>
-                  <a:srgbClr val="140C07"/>
-                </a:solidFill>
-                <a:latin typeface="Calibri" pitchFamily="34" charset="0"/>
-                <a:ea typeface="Calibri" pitchFamily="34" charset="-122"/>
-                <a:cs typeface="Calibri" pitchFamily="34" charset="-120"/>
-              </a:rPr>
-              <a:t>– $62.979</a:t>
-            </a:r>
-            <a:endParaRPr lang="en-US" sz="1400" dirty="0"/>
-          </a:p>
-        </p:txBody>
-      </p:sp>
-      <p:sp>
-        <p:nvSpPr>
-          <p:cNvPr id="9" name="Text 7"/>
-          <p:cNvSpPr/>
-          <p:nvPr/>
-        </p:nvSpPr>
-        <p:spPr>
-          <a:xfrm>
-            <a:off x="822960" y="5020056"/>
-            <a:ext cx="3108960" cy="384048"/>
-          </a:xfrm>
-          <a:prstGeom prst="rect">
-            <a:avLst/>
-          </a:prstGeom>
-          <a:noFill/>
-          <a:ln/>
-        </p:spPr>
-        <p:txBody>
-          <a:bodyPr wrap="square" lIns="0" tIns="0" rIns="0" bIns="0" rtlCol="0" anchor="ctr"/>
-          <a:lstStyle/>
-          <a:p>
-            <a:pPr indent="0" marL="0">
-              <a:buNone/>
-            </a:pPr>
-            <a:r>
-              <a:rPr lang="en-US" sz="1400" b="1" dirty="0">
-                <a:solidFill>
-                  <a:srgbClr val="140C07"/>
-                </a:solidFill>
-                <a:latin typeface="Calibri" pitchFamily="34" charset="0"/>
-                <a:ea typeface="Calibri" pitchFamily="34" charset="-122"/>
-                <a:cs typeface="Calibri" pitchFamily="34" charset="-120"/>
-              </a:rPr>
-              <a:t>Lo que recibo</a:t>
-            </a:r>
-            <a:endParaRPr lang="en-US" sz="1400" dirty="0"/>
-          </a:p>
-        </p:txBody>
-      </p:sp>
-      <p:sp>
-        <p:nvSpPr>
-          <p:cNvPr id="10" name="Text 8"/>
-          <p:cNvSpPr/>
-          <p:nvPr/>
-        </p:nvSpPr>
-        <p:spPr>
-          <a:xfrm>
-            <a:off x="3931920" y="5020056"/>
-            <a:ext cx="2011680" cy="384048"/>
-          </a:xfrm>
-          <a:prstGeom prst="rect">
-            <a:avLst/>
-          </a:prstGeom>
-          <a:noFill/>
-          <a:ln/>
-        </p:spPr>
-        <p:txBody>
-          <a:bodyPr wrap="square" lIns="0" tIns="0" rIns="0" bIns="0" rtlCol="0" anchor="ctr"/>
-          <a:lstStyle/>
-          <a:p>
-            <a:pPr algn="r" indent="0" marL="0">
-              <a:buNone/>
-            </a:pPr>
-            <a:r>
-              <a:rPr lang="en-US" sz="1400" b="1" dirty="0">
-                <a:solidFill>
-                  <a:srgbClr val="140C07"/>
-                </a:solidFill>
-                <a:latin typeface="Calibri" pitchFamily="34" charset="0"/>
-                <a:ea typeface="Calibri" pitchFamily="34" charset="-122"/>
-                <a:cs typeface="Calibri" pitchFamily="34" charset="-120"/>
-              </a:rPr>
-              <a:t>$350.000</a:t>
-            </a:r>
-            <a:endParaRPr lang="en-US" sz="1400" dirty="0"/>
-          </a:p>
-        </p:txBody>
-      </p:sp>
-      <p:sp>
-        <p:nvSpPr>
-          <p:cNvPr id="11" name="Text 9"/>
-          <p:cNvSpPr/>
-          <p:nvPr/>
-        </p:nvSpPr>
-        <p:spPr>
-          <a:xfrm>
-            <a:off x="822960" y="5596128"/>
-            <a:ext cx="5852160" cy="310896"/>
-          </a:xfrm>
-          <a:prstGeom prst="rect">
-            <a:avLst/>
-          </a:prstGeom>
-          <a:noFill/>
-          <a:ln/>
-        </p:spPr>
-        <p:txBody>
-          <a:bodyPr wrap="square" lIns="0" tIns="0" rIns="0" bIns="0" rtlCol="0" anchor="ctr"/>
-          <a:lstStyle/>
-          <a:p>
-            <a:pPr indent="0" marL="0">
-              <a:buNone/>
-            </a:pPr>
-            <a:r>
-              <a:rPr lang="en-US" sz="1250" i="1" dirty="0">
-                <a:solidFill>
-                  <a:srgbClr val="140C07"/>
-                </a:solidFill>
-                <a:latin typeface="Calibri" pitchFamily="34" charset="0"/>
-                <a:ea typeface="Calibri" pitchFamily="34" charset="-122"/>
-                <a:cs typeface="Calibri" pitchFamily="34" charset="-120"/>
-              </a:rPr>
-              <a:t>Boleta de honorarios. La retención la declara PobreVermut.</a:t>
-            </a:r>
-            <a:endParaRPr lang="en-US" sz="1250" dirty="0"/>
-          </a:p>
-        </p:txBody>
-      </p:sp>
-      <p:sp>
-        <p:nvSpPr>
-          <p:cNvPr id="12" name="Text 10"/>
-          <p:cNvSpPr/>
-          <p:nvPr/>
-        </p:nvSpPr>
-        <p:spPr>
-          <a:xfrm>
-            <a:off x="7086600" y="1783080"/>
-            <a:ext cx="4282135" cy="274320"/>
+            <a:off x="822960" y="4617720"/>
+            <a:ext cx="4846320" cy="274320"/>
           </a:xfrm>
           <a:prstGeom prst="rect">
             <a:avLst/>
@@ -3343,14 +2854,14 @@
       </p:sp>
       <p:sp>
         <p:nvSpPr>
-          <p:cNvPr id="13" name="Text 11"/>
-          <p:cNvSpPr/>
-          <p:nvPr/>
-        </p:nvSpPr>
-        <p:spPr>
-          <a:xfrm>
-            <a:off x="7086600" y="2185416"/>
-            <a:ext cx="4282135" cy="1371600"/>
+          <p:cNvPr id="6" name="Text 4"/>
+          <p:cNvSpPr/>
+          <p:nvPr/>
+        </p:nvSpPr>
+        <p:spPr>
+          <a:xfrm>
+            <a:off x="822960" y="5010912"/>
+            <a:ext cx="4846320" cy="1234440"/>
           </a:xfrm>
           <a:prstGeom prst="rect">
             <a:avLst/>
@@ -3364,12 +2875,12 @@
           <a:p>
             <a:pPr indent="0" marL="0">
               <a:lnSpc>
-                <a:spcPct val="118000"/>
+                <a:spcPct val="120000"/>
               </a:lnSpc>
               <a:buNone/>
             </a:pPr>
             <a:r>
-              <a:rPr lang="en-US" sz="1900" b="1" dirty="0">
+              <a:rPr lang="en-US" sz="1600" b="1" dirty="0">
                 <a:solidFill>
                   <a:srgbClr val="140C07"/>
                 </a:solidFill>
@@ -3379,20 +2890,20 @@
               </a:rPr>
               <a:t>Entre $200.000 y $450.000 al mes según la fase, a nombre de PobreVermut.</a:t>
             </a:r>
-            <a:endParaRPr lang="en-US" sz="1900" dirty="0"/>
-          </a:p>
-        </p:txBody>
-      </p:sp>
-      <p:sp>
-        <p:nvSpPr>
-          <p:cNvPr id="14" name="Text 12"/>
-          <p:cNvSpPr/>
-          <p:nvPr/>
-        </p:nvSpPr>
-        <p:spPr>
-          <a:xfrm>
-            <a:off x="7086600" y="4160520"/>
-            <a:ext cx="4282135" cy="274320"/>
+            <a:endParaRPr lang="en-US" sz="1600" dirty="0"/>
+          </a:p>
+        </p:txBody>
+      </p:sp>
+      <p:sp>
+        <p:nvSpPr>
+          <p:cNvPr id="7" name="Text 5"/>
+          <p:cNvSpPr/>
+          <p:nvPr/>
+        </p:nvSpPr>
+        <p:spPr>
+          <a:xfrm>
+            <a:off x="6245352" y="4617720"/>
+            <a:ext cx="4846320" cy="274320"/>
           </a:xfrm>
           <a:prstGeom prst="rect">
             <a:avLst/>
@@ -3416,7 +2927,7 @@
                 <a:ea typeface="Arial" pitchFamily="34" charset="-122"/>
                 <a:cs typeface="Arial" pitchFamily="34" charset="-120"/>
               </a:rPr>
-              <a:t>LOS PRIMEROS 3 MESES, FIJO</a:t>
+              <a:t>UN PRIMER CICLO DE TRES MESES</a:t>
             </a:r>
             <a:endParaRPr lang="en-US" sz="1050" dirty="0"/>
           </a:p>
@@ -3424,14 +2935,14 @@
       </p:sp>
       <p:sp>
         <p:nvSpPr>
-          <p:cNvPr id="15" name="Text 13"/>
-          <p:cNvSpPr/>
-          <p:nvPr/>
-        </p:nvSpPr>
-        <p:spPr>
-          <a:xfrm>
-            <a:off x="7086600" y="4562856"/>
-            <a:ext cx="4282135" cy="1371600"/>
+          <p:cNvPr id="8" name="Text 6"/>
+          <p:cNvSpPr/>
+          <p:nvPr/>
+        </p:nvSpPr>
+        <p:spPr>
+          <a:xfrm>
+            <a:off x="6245352" y="5010912"/>
+            <a:ext cx="4846320" cy="1234440"/>
           </a:xfrm>
           <a:prstGeom prst="rect">
             <a:avLst/>
@@ -3445,12 +2956,12 @@
           <a:p>
             <a:pPr indent="0" marL="0">
               <a:lnSpc>
-                <a:spcPct val="118000"/>
+                <a:spcPct val="120000"/>
               </a:lnSpc>
               <a:buNone/>
             </a:pPr>
             <a:r>
-              <a:rPr lang="en-US" sz="1900" b="1" dirty="0">
+              <a:rPr lang="en-US" sz="1600" b="1" dirty="0">
                 <a:solidFill>
                   <a:srgbClr val="140C07"/>
                 </a:solidFill>
@@ -3458,9 +2969,9 @@
                 <a:ea typeface="Arial" pitchFamily="34" charset="-122"/>
                 <a:cs typeface="Arial" pitchFamily="34" charset="-120"/>
               </a:rPr>
-              <a:t>Al mes 3 revisamos el modelo y evaluamos sumar un variable sobre las ventas del ecommerce.</a:t>
-            </a:r>
-            <a:endParaRPr lang="en-US" sz="1900" dirty="0"/>
+              <a:t>Partimos con tres meses de trabajo. Al cierre revisamos juntos los resultados y definimos cómo seguir.</a:t>
+            </a:r>
+            <a:endParaRPr lang="en-US" sz="1600" dirty="0"/>
           </a:p>
         </p:txBody>
       </p:sp>
@@ -3498,14 +3009,34 @@
       </p:grpSpPr>
       <p:sp>
         <p:nvSpPr>
-          <p:cNvPr id="2" name="Text 0"/>
-          <p:cNvSpPr/>
-          <p:nvPr/>
-        </p:nvSpPr>
-        <p:spPr>
-          <a:xfrm>
-            <a:off x="822960" y="749808"/>
-            <a:ext cx="10545775" cy="274320"/>
+          <p:cNvPr id="2" name="Shape 0"/>
+          <p:cNvSpPr/>
+          <p:nvPr/>
+        </p:nvSpPr>
+        <p:spPr>
+          <a:xfrm>
+            <a:off x="5687568" y="1691640"/>
+            <a:ext cx="822960" cy="822960"/>
+          </a:xfrm>
+          <a:prstGeom prst="ellipse">
+            <a:avLst/>
+          </a:prstGeom>
+          <a:solidFill>
+            <a:srgbClr val="EF5B25"/>
+          </a:solidFill>
+          <a:ln/>
+        </p:spPr>
+      </p:sp>
+      <p:sp>
+        <p:nvSpPr>
+          <p:cNvPr id="3" name="Text 1"/>
+          <p:cNvSpPr/>
+          <p:nvPr/>
+        </p:nvSpPr>
+        <p:spPr>
+          <a:xfrm>
+            <a:off x="1371600" y="2999232"/>
+            <a:ext cx="9445752" cy="1005840"/>
           </a:xfrm>
           <a:prstGeom prst="rect">
             <a:avLst/>
@@ -3517,82 +3048,76 @@
           <a:bodyPr wrap="square" lIns="0" tIns="0" rIns="0" bIns="0" rtlCol="0" anchor="ctr"/>
           <a:lstStyle/>
           <a:p>
-            <a:pPr indent="0" marL="0">
-              <a:buNone/>
-            </a:pPr>
-            <a:r>
-              <a:rPr lang="en-US" sz="1100" b="1" spc="250" kern="0" dirty="0">
-                <a:solidFill>
-                  <a:srgbClr val="EF5B25"/>
+            <a:pPr algn="ctr" indent="0" marL="0">
+              <a:buNone/>
+            </a:pPr>
+            <a:r>
+              <a:rPr lang="en-US" sz="5200" b="1" dirty="0">
+                <a:solidFill>
+                  <a:srgbClr val="F2EEE9"/>
                 </a:solidFill>
                 <a:latin typeface="Arial" pitchFamily="34" charset="0"/>
                 <a:ea typeface="Arial" pitchFamily="34" charset="-122"/>
                 <a:cs typeface="Arial" pitchFamily="34" charset="-120"/>
               </a:rPr>
-              <a:t>04  —  PARA PARTIR</a:t>
-            </a:r>
-            <a:endParaRPr lang="en-US" sz="1100" dirty="0"/>
-          </a:p>
-        </p:txBody>
-      </p:sp>
-      <p:sp>
-        <p:nvSpPr>
-          <p:cNvPr id="3" name="Text 1"/>
-          <p:cNvSpPr/>
-          <p:nvPr/>
-        </p:nvSpPr>
-        <p:spPr>
-          <a:xfrm>
-            <a:off x="822960" y="1133856"/>
-            <a:ext cx="10545775" cy="731520"/>
-          </a:xfrm>
-          <a:prstGeom prst="rect">
-            <a:avLst/>
-          </a:prstGeom>
-          <a:noFill/>
-          <a:ln/>
-        </p:spPr>
-        <p:txBody>
-          <a:bodyPr wrap="square" lIns="0" tIns="0" rIns="0" bIns="0" rtlCol="0" anchor="ctr"/>
-          <a:lstStyle/>
-          <a:p>
-            <a:pPr indent="0" marL="0">
-              <a:buNone/>
-            </a:pPr>
-            <a:r>
-              <a:rPr lang="en-US" sz="3800" b="1" dirty="0">
-                <a:solidFill>
-                  <a:srgbClr val="F2EEE9"/>
+              <a:t>Trabajemos </a:t>
+            </a:r>
+            <a:pPr algn="ctr" indent="0" marL="0">
+              <a:buNone/>
+            </a:pPr>
+            <a:r>
+              <a:rPr lang="en-US" sz="5200" b="1" dirty="0">
+                <a:solidFill>
+                  <a:srgbClr val="EF5B25"/>
                 </a:solidFill>
                 <a:latin typeface="Arial" pitchFamily="34" charset="0"/>
                 <a:ea typeface="Arial" pitchFamily="34" charset="-122"/>
                 <a:cs typeface="Arial" pitchFamily="34" charset="-120"/>
               </a:rPr>
-              <a:t>Qué necesito</a:t>
-            </a:r>
-            <a:endParaRPr lang="en-US" sz="3800" dirty="0"/>
-          </a:p>
-        </p:txBody>
-      </p:sp>
-      <p:sp>
-        <p:nvSpPr>
-          <p:cNvPr id="4" name="Shape 2"/>
-          <p:cNvSpPr/>
-          <p:nvPr/>
-        </p:nvSpPr>
-        <p:spPr>
-          <a:xfrm>
-            <a:off x="822960" y="2688336"/>
-            <a:ext cx="146304" cy="146304"/>
-          </a:xfrm>
-          <a:prstGeom prst="ellipse">
-            <a:avLst/>
-          </a:prstGeom>
-          <a:solidFill>
-            <a:srgbClr val="EF5B25"/>
-          </a:solidFill>
-          <a:ln/>
-        </p:spPr>
+              <a:t>juntos.</a:t>
+            </a:r>
+            <a:endParaRPr lang="en-US" sz="5200" dirty="0"/>
+          </a:p>
+        </p:txBody>
+      </p:sp>
+      <p:sp>
+        <p:nvSpPr>
+          <p:cNvPr id="4" name="Text 2"/>
+          <p:cNvSpPr/>
+          <p:nvPr/>
+        </p:nvSpPr>
+        <p:spPr>
+          <a:xfrm>
+            <a:off x="1371600" y="4709160"/>
+            <a:ext cx="9445752" cy="329184"/>
+          </a:xfrm>
+          <a:prstGeom prst="rect">
+            <a:avLst/>
+          </a:prstGeom>
+          <a:noFill/>
+          <a:ln/>
+        </p:spPr>
+        <p:txBody>
+          <a:bodyPr wrap="square" lIns="0" tIns="0" rIns="0" bIns="0" rtlCol="0" anchor="ctr"/>
+          <a:lstStyle/>
+          <a:p>
+            <a:pPr algn="ctr" indent="0" marL="0">
+              <a:buNone/>
+            </a:pPr>
+            <a:r>
+              <a:rPr lang="en-US" sz="1600" b="1" dirty="0">
+                <a:solidFill>
+                  <a:srgbClr val="F2EEE9"/>
+                </a:solidFill>
+                <a:latin typeface="Arial" pitchFamily="34" charset="0"/>
+                <a:ea typeface="Arial" pitchFamily="34" charset="-122"/>
+                <a:cs typeface="Arial" pitchFamily="34" charset="-120"/>
+              </a:rPr>
+              <a:t>Nicolás</a:t>
+            </a:r>
+            <a:endParaRPr lang="en-US" sz="1600" dirty="0"/>
+          </a:p>
+        </p:txBody>
       </p:sp>
       <p:sp>
         <p:nvSpPr>
@@ -3602,8 +3127,8 @@
         </p:nvSpPr>
         <p:spPr>
           <a:xfrm>
-            <a:off x="1261872" y="2514600"/>
-            <a:ext cx="5943600" cy="475488"/>
+            <a:off x="1371600" y="5065776"/>
+            <a:ext cx="9445752" cy="329184"/>
           </a:xfrm>
           <a:prstGeom prst="rect">
             <a:avLst/>
@@ -3615,420 +3140,21 @@
           <a:bodyPr wrap="square" lIns="0" tIns="0" rIns="0" bIns="0" rtlCol="0" anchor="ctr"/>
           <a:lstStyle/>
           <a:p>
-            <a:pPr indent="0" marL="0">
-              <a:buNone/>
-            </a:pPr>
-            <a:r>
-              <a:rPr lang="en-US" sz="1700" dirty="0">
-                <a:solidFill>
-                  <a:srgbClr val="F2EEE9"/>
+            <a:pPr algn="ctr" indent="0" marL="0">
+              <a:buNone/>
+            </a:pPr>
+            <a:r>
+              <a:rPr lang="en-US" sz="1500" dirty="0">
+                <a:solidFill>
+                  <a:srgbClr val="8A807A"/>
                 </a:solidFill>
                 <a:latin typeface="Calibri" pitchFamily="34" charset="0"/>
                 <a:ea typeface="Calibri" pitchFamily="34" charset="-122"/>
                 <a:cs typeface="Calibri" pitchFamily="34" charset="-120"/>
               </a:rPr>
-              <a:t>Accesos a Meta, Instagram y Facebook</a:t>
-            </a:r>
-            <a:endParaRPr lang="en-US" sz="1700" dirty="0"/>
-          </a:p>
-        </p:txBody>
-      </p:sp>
-      <p:sp>
-        <p:nvSpPr>
-          <p:cNvPr id="6" name="Shape 4"/>
-          <p:cNvSpPr/>
-          <p:nvPr/>
-        </p:nvSpPr>
-        <p:spPr>
-          <a:xfrm>
-            <a:off x="822960" y="3383280"/>
-            <a:ext cx="146304" cy="146304"/>
-          </a:xfrm>
-          <a:prstGeom prst="ellipse">
-            <a:avLst/>
-          </a:prstGeom>
-          <a:solidFill>
-            <a:srgbClr val="EF5B25"/>
-          </a:solidFill>
-          <a:ln/>
-        </p:spPr>
-      </p:sp>
-      <p:sp>
-        <p:nvSpPr>
-          <p:cNvPr id="7" name="Text 5"/>
-          <p:cNvSpPr/>
-          <p:nvPr/>
-        </p:nvSpPr>
-        <p:spPr>
-          <a:xfrm>
-            <a:off x="1261872" y="3209544"/>
-            <a:ext cx="5943600" cy="475488"/>
-          </a:xfrm>
-          <a:prstGeom prst="rect">
-            <a:avLst/>
-          </a:prstGeom>
-          <a:noFill/>
-          <a:ln/>
-        </p:spPr>
-        <p:txBody>
-          <a:bodyPr wrap="square" lIns="0" tIns="0" rIns="0" bIns="0" rtlCol="0" anchor="ctr"/>
-          <a:lstStyle/>
-          <a:p>
-            <a:pPr indent="0" marL="0">
-              <a:buNone/>
-            </a:pPr>
-            <a:r>
-              <a:rPr lang="en-US" sz="1700" dirty="0">
-                <a:solidFill>
-                  <a:srgbClr val="F2EEE9"/>
-                </a:solidFill>
-                <a:latin typeface="Calibri" pitchFamily="34" charset="0"/>
-                <a:ea typeface="Calibri" pitchFamily="34" charset="-122"/>
-                <a:cs typeface="Calibri" pitchFamily="34" charset="-120"/>
-              </a:rPr>
-              <a:t>Acceso al ecommerce para píxel y catálogo</a:t>
-            </a:r>
-            <a:endParaRPr lang="en-US" sz="1700" dirty="0"/>
-          </a:p>
-        </p:txBody>
-      </p:sp>
-      <p:sp>
-        <p:nvSpPr>
-          <p:cNvPr id="8" name="Shape 6"/>
-          <p:cNvSpPr/>
-          <p:nvPr/>
-        </p:nvSpPr>
-        <p:spPr>
-          <a:xfrm>
-            <a:off x="822960" y="4078224"/>
-            <a:ext cx="146304" cy="146304"/>
-          </a:xfrm>
-          <a:prstGeom prst="ellipse">
-            <a:avLst/>
-          </a:prstGeom>
-          <a:solidFill>
-            <a:srgbClr val="EF5B25"/>
-          </a:solidFill>
-          <a:ln/>
-        </p:spPr>
-      </p:sp>
-      <p:sp>
-        <p:nvSpPr>
-          <p:cNvPr id="9" name="Text 7"/>
-          <p:cNvSpPr/>
-          <p:nvPr/>
-        </p:nvSpPr>
-        <p:spPr>
-          <a:xfrm>
-            <a:off x="1261872" y="3904488"/>
-            <a:ext cx="5943600" cy="475488"/>
-          </a:xfrm>
-          <a:prstGeom prst="rect">
-            <a:avLst/>
-          </a:prstGeom>
-          <a:noFill/>
-          <a:ln/>
-        </p:spPr>
-        <p:txBody>
-          <a:bodyPr wrap="square" lIns="0" tIns="0" rIns="0" bIns="0" rtlCol="0" anchor="ctr"/>
-          <a:lstStyle/>
-          <a:p>
-            <a:pPr indent="0" marL="0">
-              <a:buNone/>
-            </a:pPr>
-            <a:r>
-              <a:rPr lang="en-US" sz="1700" dirty="0">
-                <a:solidFill>
-                  <a:srgbClr val="F2EEE9"/>
-                </a:solidFill>
-                <a:latin typeface="Calibri" pitchFamily="34" charset="0"/>
-                <a:ea typeface="Calibri" pitchFamily="34" charset="-122"/>
-                <a:cs typeface="Calibri" pitchFamily="34" charset="-120"/>
-              </a:rPr>
-              <a:t>Presupuesto de pauta confirmado</a:t>
-            </a:r>
-            <a:endParaRPr lang="en-US" sz="1700" dirty="0"/>
-          </a:p>
-        </p:txBody>
-      </p:sp>
-      <p:sp>
-        <p:nvSpPr>
-          <p:cNvPr id="10" name="Shape 8"/>
-          <p:cNvSpPr/>
-          <p:nvPr/>
-        </p:nvSpPr>
-        <p:spPr>
-          <a:xfrm>
-            <a:off x="822960" y="4773168"/>
-            <a:ext cx="146304" cy="146304"/>
-          </a:xfrm>
-          <a:prstGeom prst="ellipse">
-            <a:avLst/>
-          </a:prstGeom>
-          <a:solidFill>
-            <a:srgbClr val="EF5B25"/>
-          </a:solidFill>
-          <a:ln/>
-        </p:spPr>
-      </p:sp>
-      <p:sp>
-        <p:nvSpPr>
-          <p:cNvPr id="11" name="Text 9"/>
-          <p:cNvSpPr/>
-          <p:nvPr/>
-        </p:nvSpPr>
-        <p:spPr>
-          <a:xfrm>
-            <a:off x="1261872" y="4599432"/>
-            <a:ext cx="5943600" cy="475488"/>
-          </a:xfrm>
-          <a:prstGeom prst="rect">
-            <a:avLst/>
-          </a:prstGeom>
-          <a:noFill/>
-          <a:ln/>
-        </p:spPr>
-        <p:txBody>
-          <a:bodyPr wrap="square" lIns="0" tIns="0" rIns="0" bIns="0" rtlCol="0" anchor="ctr"/>
-          <a:lstStyle/>
-          <a:p>
-            <a:pPr indent="0" marL="0">
-              <a:buNone/>
-            </a:pPr>
-            <a:r>
-              <a:rPr lang="en-US" sz="1700" dirty="0">
-                <a:solidFill>
-                  <a:srgbClr val="F2EEE9"/>
-                </a:solidFill>
-                <a:latin typeface="Calibri" pitchFamily="34" charset="0"/>
-                <a:ea typeface="Calibri" pitchFamily="34" charset="-122"/>
-                <a:cs typeface="Calibri" pitchFamily="34" charset="-120"/>
-              </a:rPr>
-              <a:t>Creativos del equipo creativo</a:t>
-            </a:r>
-            <a:endParaRPr lang="en-US" sz="1700" dirty="0"/>
-          </a:p>
-        </p:txBody>
-      </p:sp>
-      <p:sp>
-        <p:nvSpPr>
-          <p:cNvPr id="12" name="Shape 10"/>
-          <p:cNvSpPr/>
-          <p:nvPr/>
-        </p:nvSpPr>
-        <p:spPr>
-          <a:xfrm>
-            <a:off x="822960" y="5468112"/>
-            <a:ext cx="146304" cy="146304"/>
-          </a:xfrm>
-          <a:prstGeom prst="ellipse">
-            <a:avLst/>
-          </a:prstGeom>
-          <a:solidFill>
-            <a:srgbClr val="EF5B25"/>
-          </a:solidFill>
-          <a:ln/>
-        </p:spPr>
-      </p:sp>
-      <p:sp>
-        <p:nvSpPr>
-          <p:cNvPr id="13" name="Text 11"/>
-          <p:cNvSpPr/>
-          <p:nvPr/>
-        </p:nvSpPr>
-        <p:spPr>
-          <a:xfrm>
-            <a:off x="1261872" y="5294376"/>
-            <a:ext cx="5943600" cy="475488"/>
-          </a:xfrm>
-          <a:prstGeom prst="rect">
-            <a:avLst/>
-          </a:prstGeom>
-          <a:noFill/>
-          <a:ln/>
-        </p:spPr>
-        <p:txBody>
-          <a:bodyPr wrap="square" lIns="0" tIns="0" rIns="0" bIns="0" rtlCol="0" anchor="ctr"/>
-          <a:lstStyle/>
-          <a:p>
-            <a:pPr indent="0" marL="0">
-              <a:buNone/>
-            </a:pPr>
-            <a:r>
-              <a:rPr lang="en-US" sz="1700" dirty="0">
-                <a:solidFill>
-                  <a:srgbClr val="F2EEE9"/>
-                </a:solidFill>
-                <a:latin typeface="Calibri" pitchFamily="34" charset="0"/>
-                <a:ea typeface="Calibri" pitchFamily="34" charset="-122"/>
-                <a:cs typeface="Calibri" pitchFamily="34" charset="-120"/>
-              </a:rPr>
-              <a:t>Un kickoff de 45 minutos</a:t>
-            </a:r>
-            <a:endParaRPr lang="en-US" sz="1700" dirty="0"/>
-          </a:p>
-        </p:txBody>
-      </p:sp>
-      <p:sp>
-        <p:nvSpPr>
-          <p:cNvPr id="14" name="Text 12"/>
-          <p:cNvSpPr/>
-          <p:nvPr/>
-        </p:nvSpPr>
-        <p:spPr>
-          <a:xfrm>
-            <a:off x="7589520" y="2468880"/>
-            <a:ext cx="3779215" cy="1554480"/>
-          </a:xfrm>
-          <a:prstGeom prst="rect">
-            <a:avLst/>
-          </a:prstGeom>
-          <a:noFill/>
-          <a:ln/>
-        </p:spPr>
-        <p:txBody>
-          <a:bodyPr wrap="square" lIns="0" tIns="0" rIns="0" bIns="0" rtlCol="0" anchor="t"/>
-          <a:lstStyle/>
-          <a:p>
-            <a:pPr indent="0" marL="0">
-              <a:lnSpc>
-                <a:spcPct val="108000"/>
-              </a:lnSpc>
-              <a:buNone/>
-            </a:pPr>
-            <a:r>
-              <a:rPr lang="en-US" sz="3000" b="1" dirty="0">
-                <a:solidFill>
-                  <a:srgbClr val="EF5B25"/>
-                </a:solidFill>
-                <a:latin typeface="Arial" pitchFamily="34" charset="0"/>
-                <a:ea typeface="Arial" pitchFamily="34" charset="-122"/>
-                <a:cs typeface="Arial" pitchFamily="34" charset="-120"/>
-              </a:rPr>
-              <a:t>Campañas activas</a:t>
-            </a:r>
-            <a:endParaRPr lang="en-US" sz="3000" dirty="0"/>
-          </a:p>
-          <a:p>
-            <a:pPr indent="0" marL="0">
-              <a:lnSpc>
-                <a:spcPct val="108000"/>
-              </a:lnSpc>
-              <a:buNone/>
-            </a:pPr>
-            <a:r>
-              <a:rPr lang="en-US" sz="3000" b="1" dirty="0">
-                <a:solidFill>
-                  <a:srgbClr val="EF5B25"/>
-                </a:solidFill>
-                <a:latin typeface="Arial" pitchFamily="34" charset="0"/>
-                <a:ea typeface="Arial" pitchFamily="34" charset="-122"/>
-                <a:cs typeface="Arial" pitchFamily="34" charset="-120"/>
-              </a:rPr>
-              <a:t>en dos semanas.</a:t>
-            </a:r>
-            <a:endParaRPr lang="en-US" sz="3000" dirty="0"/>
-          </a:p>
-        </p:txBody>
-      </p:sp>
-      <p:sp>
-        <p:nvSpPr>
-          <p:cNvPr id="15" name="Text 13"/>
-          <p:cNvSpPr/>
-          <p:nvPr/>
-        </p:nvSpPr>
-        <p:spPr>
-          <a:xfrm>
-            <a:off x="7589520" y="4160520"/>
-            <a:ext cx="3779215" cy="310896"/>
-          </a:xfrm>
-          <a:prstGeom prst="rect">
-            <a:avLst/>
-          </a:prstGeom>
-          <a:noFill/>
-          <a:ln/>
-        </p:spPr>
-        <p:txBody>
-          <a:bodyPr wrap="square" lIns="0" tIns="0" rIns="0" bIns="0" rtlCol="0" anchor="ctr"/>
-          <a:lstStyle/>
-          <a:p>
-            <a:pPr indent="0" marL="0">
-              <a:buNone/>
-            </a:pPr>
-            <a:r>
-              <a:rPr lang="en-US" sz="1500" b="1" dirty="0">
-                <a:solidFill>
-                  <a:srgbClr val="F2EEE9"/>
-                </a:solidFill>
-                <a:latin typeface="Arial" pitchFamily="34" charset="0"/>
-                <a:ea typeface="Arial" pitchFamily="34" charset="-122"/>
-                <a:cs typeface="Arial" pitchFamily="34" charset="-120"/>
-              </a:rPr>
-              <a:t>Nicolás</a:t>
+              <a:t>nicolas@sherpasstudio.cl  ·  +56 9 3125 6539</a:t>
             </a:r>
             <a:endParaRPr lang="en-US" sz="1500" dirty="0"/>
-          </a:p>
-        </p:txBody>
-      </p:sp>
-      <p:sp>
-        <p:nvSpPr>
-          <p:cNvPr id="16" name="Text 14"/>
-          <p:cNvSpPr/>
-          <p:nvPr/>
-        </p:nvSpPr>
-        <p:spPr>
-          <a:xfrm>
-            <a:off x="7589520" y="4498848"/>
-            <a:ext cx="3779215" cy="621792"/>
-          </a:xfrm>
-          <a:prstGeom prst="rect">
-            <a:avLst/>
-          </a:prstGeom>
-          <a:noFill/>
-          <a:ln/>
-        </p:spPr>
-        <p:txBody>
-          <a:bodyPr wrap="square" lIns="0" tIns="0" rIns="0" bIns="0" rtlCol="0" anchor="ctr"/>
-          <a:lstStyle/>
-          <a:p>
-            <a:pPr indent="0" marL="0">
-              <a:lnSpc>
-                <a:spcPct val="125000"/>
-              </a:lnSpc>
-              <a:buNone/>
-            </a:pPr>
-            <a:r>
-              <a:rPr lang="en-US" sz="1400" dirty="0">
-                <a:solidFill>
-                  <a:srgbClr val="8A807A"/>
-                </a:solidFill>
-                <a:latin typeface="Calibri" pitchFamily="34" charset="0"/>
-                <a:ea typeface="Calibri" pitchFamily="34" charset="-122"/>
-                <a:cs typeface="Calibri" pitchFamily="34" charset="-120"/>
-              </a:rPr>
-              <a:t>nicolas@sherpasstudio.cl</a:t>
-            </a:r>
-            <a:endParaRPr lang="en-US" sz="1400" dirty="0"/>
-          </a:p>
-          <a:p>
-            <a:pPr indent="0" marL="0">
-              <a:lnSpc>
-                <a:spcPct val="125000"/>
-              </a:lnSpc>
-              <a:buNone/>
-            </a:pPr>
-            <a:r>
-              <a:rPr lang="en-US" sz="1400" dirty="0">
-                <a:solidFill>
-                  <a:srgbClr val="8A807A"/>
-                </a:solidFill>
-                <a:latin typeface="Calibri" pitchFamily="34" charset="0"/>
-                <a:ea typeface="Calibri" pitchFamily="34" charset="-122"/>
-                <a:cs typeface="Calibri" pitchFamily="34" charset="-120"/>
-              </a:rPr>
-              <a:t>+56 9 3125 6539</a:t>
-            </a:r>
-            <a:endParaRPr lang="en-US" sz="1400" dirty="0"/>
           </a:p>
         </p:txBody>
       </p:sp>

</xml_diff>

<commit_message>
Alinea la propuesta de PobreVermut con la identidad de la marca
Reemplaza la paleta inventada de tinta y naranja por los colores reales de
PobreVermut, muestreados del PDF de la barra: púrpura con magenta para el
grueso del deck y teal con verde para el bloque del honorario, replicando
cómo la marca presenta el precio en su propio material.

Cambia la tipografía a caja alta con monoespaciada para etiquetas y texto,
siguiendo el sistema de la marca.

Incorpora dos activos extraídos del PDF y recortados con canal alfa: el vaso
de línea, que reemplaza al círculo como motivo, y la bajada manuscrita
"Salud, vermút y buena vida" en el cierre.

Co-Authored-By: Claude Opus 5 <noreply@anthropic.com>
Claude-Session: https://claude.ai/code/session_01TbbPRaX9MW6Lcxus2ycV3h
</commit_message>
<xml_diff>
--- a/propuestas/pobrevermut/PobreVermut - Propuesta Campanas 2026.pptx
+++ b/propuestas/pobrevermut/PobreVermut - Propuesta Campanas 2026.pptx
@@ -1213,7 +1213,7 @@
     <p:bg>
       <p:bgPr>
         <a:solidFill>
-          <a:srgbClr val="0F0E0D"/>
+          <a:srgbClr val="3A1842"/>
         </a:solidFill>
       </p:bgPr>
     </p:bg>
@@ -1231,36 +1231,40 @@
           <a:chExt cx="0" cy="0"/>
         </a:xfrm>
       </p:grpSpPr>
-      <p:sp>
-        <p:nvSpPr>
-          <p:cNvPr id="2" name="Shape 0"/>
-          <p:cNvSpPr/>
-          <p:nvPr/>
-        </p:nvSpPr>
-        <p:spPr>
-          <a:xfrm>
-            <a:off x="9006840" y="2487168"/>
-            <a:ext cx="2377440" cy="2377440"/>
-          </a:xfrm>
-          <a:prstGeom prst="ellipse">
-            <a:avLst/>
-          </a:prstGeom>
-          <a:solidFill>
-            <a:srgbClr val="EF5B25"/>
-          </a:solidFill>
-          <a:ln/>
-        </p:spPr>
-      </p:sp>
-      <p:sp>
-        <p:nvSpPr>
-          <p:cNvPr id="3" name="Text 1"/>
-          <p:cNvSpPr/>
-          <p:nvPr/>
-        </p:nvSpPr>
-        <p:spPr>
-          <a:xfrm>
-            <a:off x="822960" y="868680"/>
-            <a:ext cx="6400800" cy="310896"/>
+      <p:pic>
+        <p:nvPicPr>
+          <p:cNvPr id="2" name="Image 0" descr="/tmp/claude-0/-home-user-Gmb-Aagent/415d07b8-2eab-51b2-81d2-2f92b3b46afc/scratchpad/marca/vaso-magenta.png">    </p:cNvPr>
+          <p:cNvPicPr>
+            <a:picLocks noChangeAspect="1"/>
+          </p:cNvPicPr>
+          <p:nvPr/>
+        </p:nvPicPr>
+        <p:blipFill>
+          <a:blip r:embed="rId1"/>
+          <a:stretch>
+            <a:fillRect/>
+          </a:stretch>
+        </p:blipFill>
+        <p:spPr>
+          <a:xfrm>
+            <a:off x="9555480" y="1847088"/>
+            <a:ext cx="1792224" cy="2843784"/>
+          </a:xfrm>
+          <a:prstGeom prst="rect">
+            <a:avLst/>
+          </a:prstGeom>
+        </p:spPr>
+      </p:pic>
+      <p:sp>
+        <p:nvSpPr>
+          <p:cNvPr id="3" name="Text 0"/>
+          <p:cNvSpPr/>
+          <p:nvPr/>
+        </p:nvSpPr>
+        <p:spPr>
+          <a:xfrm>
+            <a:off x="822960" y="804672"/>
+            <a:ext cx="6858000" cy="347472"/>
           </a:xfrm>
           <a:prstGeom prst="rect">
             <a:avLst/>
@@ -1276,9 +1280,9 @@
               <a:buNone/>
             </a:pPr>
             <a:r>
-              <a:rPr lang="en-US" sz="1200" b="1" spc="600" kern="0" dirty="0">
-                <a:solidFill>
-                  <a:srgbClr val="EF5B25"/>
+              <a:rPr lang="en-US" sz="1500" spc="900" kern="0" dirty="0">
+                <a:solidFill>
+                  <a:srgbClr val="FFFFFF"/>
                 </a:solidFill>
                 <a:latin typeface="Arial" pitchFamily="34" charset="0"/>
                 <a:ea typeface="Arial" pitchFamily="34" charset="-122"/>
@@ -1286,20 +1290,20 @@
               </a:rPr>
               <a:t>POBREVERMUT</a:t>
             </a:r>
-            <a:endParaRPr lang="en-US" sz="1200" dirty="0"/>
-          </a:p>
-        </p:txBody>
-      </p:sp>
-      <p:sp>
-        <p:nvSpPr>
-          <p:cNvPr id="4" name="Text 2"/>
-          <p:cNvSpPr/>
-          <p:nvPr/>
-        </p:nvSpPr>
-        <p:spPr>
-          <a:xfrm>
-            <a:off x="822960" y="2743200"/>
-            <a:ext cx="7863840" cy="1920240"/>
+            <a:endParaRPr lang="en-US" sz="1500" dirty="0"/>
+          </a:p>
+        </p:txBody>
+      </p:sp>
+      <p:sp>
+        <p:nvSpPr>
+          <p:cNvPr id="4" name="Text 1"/>
+          <p:cNvSpPr/>
+          <p:nvPr/>
+        </p:nvSpPr>
+        <p:spPr>
+          <a:xfrm>
+            <a:off x="822960" y="2423160"/>
+            <a:ext cx="8412480" cy="2011680"/>
           </a:xfrm>
           <a:prstGeom prst="rect">
             <a:avLst/>
@@ -1313,40 +1317,40 @@
           <a:p>
             <a:pPr indent="0" marL="0">
               <a:lnSpc>
-                <a:spcPct val="102000"/>
+                <a:spcPct val="100000"/>
               </a:lnSpc>
               <a:buNone/>
             </a:pPr>
             <a:r>
               <a:rPr lang="en-US" sz="5400" b="1" dirty="0">
                 <a:solidFill>
-                  <a:srgbClr val="F2EEE9"/>
+                  <a:srgbClr val="FFFFFF"/>
                 </a:solidFill>
                 <a:latin typeface="Arial" pitchFamily="34" charset="0"/>
                 <a:ea typeface="Arial" pitchFamily="34" charset="-122"/>
                 <a:cs typeface="Arial" pitchFamily="34" charset="-120"/>
               </a:rPr>
-              <a:t>Campañas para</a:t>
+              <a:t>CAMPAÑAS PARA</a:t>
             </a:r>
             <a:endParaRPr lang="en-US" sz="5400" dirty="0"/>
           </a:p>
           <a:p>
             <a:pPr indent="0" marL="0">
               <a:lnSpc>
-                <a:spcPct val="102000"/>
+                <a:spcPct val="100000"/>
               </a:lnSpc>
               <a:buNone/>
             </a:pPr>
             <a:r>
               <a:rPr lang="en-US" sz="5400" b="1" dirty="0">
                 <a:solidFill>
-                  <a:srgbClr val="EF5B25"/>
+                  <a:srgbClr val="DE27A0"/>
                 </a:solidFill>
                 <a:latin typeface="Arial" pitchFamily="34" charset="0"/>
                 <a:ea typeface="Arial" pitchFamily="34" charset="-122"/>
                 <a:cs typeface="Arial" pitchFamily="34" charset="-120"/>
               </a:rPr>
-              <a:t>vender online</a:t>
+              <a:t>VENDER ONLINE</a:t>
             </a:r>
             <a:endParaRPr lang="en-US" sz="5400" dirty="0"/>
           </a:p>
@@ -1354,14 +1358,14 @@
       </p:sp>
       <p:sp>
         <p:nvSpPr>
-          <p:cNvPr id="5" name="Text 3"/>
-          <p:cNvSpPr/>
-          <p:nvPr/>
-        </p:nvSpPr>
-        <p:spPr>
-          <a:xfrm>
-            <a:off x="822960" y="4828032"/>
-            <a:ext cx="7863840" cy="365760"/>
+          <p:cNvPr id="5" name="Text 2"/>
+          <p:cNvSpPr/>
+          <p:nvPr/>
+        </p:nvSpPr>
+        <p:spPr>
+          <a:xfrm>
+            <a:off x="822960" y="4663440"/>
+            <a:ext cx="8412480" cy="310896"/>
           </a:xfrm>
           <a:prstGeom prst="rect">
             <a:avLst/>
@@ -1377,30 +1381,30 @@
               <a:buNone/>
             </a:pPr>
             <a:r>
-              <a:rPr lang="en-US" sz="1700" dirty="0">
-                <a:solidFill>
-                  <a:srgbClr val="8A807A"/>
-                </a:solidFill>
-                <a:latin typeface="Calibri" pitchFamily="34" charset="0"/>
-                <a:ea typeface="Calibri" pitchFamily="34" charset="-122"/>
-                <a:cs typeface="Calibri" pitchFamily="34" charset="-120"/>
-              </a:rPr>
-              <a:t>Ya hay marca, comunidad y ecommerce. Ahora, a vender.</a:t>
-            </a:r>
-            <a:endParaRPr lang="en-US" sz="1700" dirty="0"/>
-          </a:p>
-        </p:txBody>
-      </p:sp>
-      <p:sp>
-        <p:nvSpPr>
-          <p:cNvPr id="6" name="Text 4"/>
-          <p:cNvSpPr/>
-          <p:nvPr/>
-        </p:nvSpPr>
-        <p:spPr>
-          <a:xfrm>
-            <a:off x="822960" y="5742432"/>
-            <a:ext cx="5486400" cy="274320"/>
+              <a:rPr lang="en-US" sz="1200" b="1" spc="100" kern="0" dirty="0">
+                <a:solidFill>
+                  <a:srgbClr val="BFA3C8"/>
+                </a:solidFill>
+                <a:latin typeface="Courier New" pitchFamily="34" charset="0"/>
+                <a:ea typeface="Courier New" pitchFamily="34" charset="-122"/>
+                <a:cs typeface="Courier New" pitchFamily="34" charset="-120"/>
+              </a:rPr>
+              <a:t>YA HAY MARCA, COMUNIDAD Y ECOMMERCE. AHORA, A VENDER.</a:t>
+            </a:r>
+            <a:endParaRPr lang="en-US" sz="1200" dirty="0"/>
+          </a:p>
+        </p:txBody>
+      </p:sp>
+      <p:sp>
+        <p:nvSpPr>
+          <p:cNvPr id="6" name="Text 3"/>
+          <p:cNvSpPr/>
+          <p:nvPr/>
+        </p:nvSpPr>
+        <p:spPr>
+          <a:xfrm>
+            <a:off x="822960" y="5705856"/>
+            <a:ext cx="5943600" cy="274320"/>
           </a:xfrm>
           <a:prstGeom prst="rect">
             <a:avLst/>
@@ -1416,30 +1420,30 @@
               <a:buNone/>
             </a:pPr>
             <a:r>
-              <a:rPr lang="en-US" sz="1300" dirty="0">
-                <a:solidFill>
-                  <a:srgbClr val="8A807A"/>
-                </a:solidFill>
-                <a:latin typeface="Calibri" pitchFamily="34" charset="0"/>
-                <a:ea typeface="Calibri" pitchFamily="34" charset="-122"/>
-                <a:cs typeface="Calibri" pitchFamily="34" charset="-120"/>
-              </a:rPr>
-              <a:t>Propuesta  ·  Agosto 2026</a:t>
-            </a:r>
-            <a:endParaRPr lang="en-US" sz="1300" dirty="0"/>
-          </a:p>
-        </p:txBody>
-      </p:sp>
-      <p:sp>
-        <p:nvSpPr>
-          <p:cNvPr id="7" name="Text 5"/>
+              <a:rPr lang="en-US" sz="1100" b="1" spc="100" kern="0" dirty="0">
+                <a:solidFill>
+                  <a:srgbClr val="BFA3C8"/>
+                </a:solidFill>
+                <a:latin typeface="Courier New" pitchFamily="34" charset="0"/>
+                <a:ea typeface="Courier New" pitchFamily="34" charset="-122"/>
+                <a:cs typeface="Courier New" pitchFamily="34" charset="-120"/>
+              </a:rPr>
+              <a:t>PROPUESTA  ·  AGOSTO 2026</a:t>
+            </a:r>
+            <a:endParaRPr lang="en-US" sz="1100" dirty="0"/>
+          </a:p>
+        </p:txBody>
+      </p:sp>
+      <p:sp>
+        <p:nvSpPr>
+          <p:cNvPr id="7" name="Text 4"/>
           <p:cNvSpPr/>
           <p:nvPr/>
         </p:nvSpPr>
         <p:spPr>
           <a:xfrm>
             <a:off x="822960" y="6035040"/>
-            <a:ext cx="5486400" cy="274320"/>
+            <a:ext cx="5943600" cy="274320"/>
           </a:xfrm>
           <a:prstGeom prst="rect">
             <a:avLst/>
@@ -1455,17 +1459,17 @@
               <a:buNone/>
             </a:pPr>
             <a:r>
-              <a:rPr lang="en-US" sz="1300" b="1" dirty="0">
-                <a:solidFill>
-                  <a:srgbClr val="F2EEE9"/>
-                </a:solidFill>
-                <a:latin typeface="Calibri" pitchFamily="34" charset="0"/>
-                <a:ea typeface="Calibri" pitchFamily="34" charset="-122"/>
-                <a:cs typeface="Calibri" pitchFamily="34" charset="-120"/>
-              </a:rPr>
-              <a:t>Nicolás  ·  nicolas@sherpasstudio.cl</a:t>
-            </a:r>
-            <a:endParaRPr lang="en-US" sz="1300" dirty="0"/>
+              <a:rPr lang="en-US" sz="1100" b="1" spc="100" kern="0" dirty="0">
+                <a:solidFill>
+                  <a:srgbClr val="FFFFFF"/>
+                </a:solidFill>
+                <a:latin typeface="Courier New" pitchFamily="34" charset="0"/>
+                <a:ea typeface="Courier New" pitchFamily="34" charset="-122"/>
+                <a:cs typeface="Courier New" pitchFamily="34" charset="-120"/>
+              </a:rPr>
+              <a:t>NICOLÁS  ·  NICOLAS@SHERPASSTUDIO.CL</a:t>
+            </a:r>
+            <a:endParaRPr lang="en-US" sz="1100" dirty="0"/>
           </a:p>
         </p:txBody>
       </p:sp>
@@ -1483,7 +1487,7 @@
     <p:bg>
       <p:bgPr>
         <a:solidFill>
-          <a:srgbClr val="0F0E0D"/>
+          <a:srgbClr val="3A1842"/>
         </a:solidFill>
       </p:bgPr>
     </p:bg>
@@ -1526,15 +1530,93 @@
               <a:buNone/>
             </a:pPr>
             <a:r>
-              <a:rPr lang="en-US" sz="1100" b="1" spc="250" kern="0" dirty="0">
-                <a:solidFill>
-                  <a:srgbClr val="EF5B25"/>
+              <a:rPr lang="en-US" sz="1200" b="1" spc="200" kern="0" dirty="0">
+                <a:solidFill>
+                  <a:srgbClr val="DE27A0"/>
+                </a:solidFill>
+                <a:latin typeface="Courier New" pitchFamily="34" charset="0"/>
+                <a:ea typeface="Courier New" pitchFamily="34" charset="-122"/>
+                <a:cs typeface="Courier New" pitchFamily="34" charset="-120"/>
+              </a:rPr>
+              <a:t>01  —  EL PLAN</a:t>
+            </a:r>
+            <a:endParaRPr lang="en-US" sz="1200" dirty="0"/>
+          </a:p>
+        </p:txBody>
+      </p:sp>
+      <p:sp>
+        <p:nvSpPr>
+          <p:cNvPr id="3" name="Text 1"/>
+          <p:cNvSpPr/>
+          <p:nvPr/>
+        </p:nvSpPr>
+        <p:spPr>
+          <a:xfrm>
+            <a:off x="822960" y="1152144"/>
+            <a:ext cx="10545775" cy="731520"/>
+          </a:xfrm>
+          <a:prstGeom prst="rect">
+            <a:avLst/>
+          </a:prstGeom>
+          <a:noFill/>
+          <a:ln/>
+        </p:spPr>
+        <p:txBody>
+          <a:bodyPr wrap="square" lIns="0" tIns="0" rIns="0" bIns="0" rtlCol="0" anchor="ctr"/>
+          <a:lstStyle/>
+          <a:p>
+            <a:pPr indent="0" marL="0">
+              <a:buNone/>
+            </a:pPr>
+            <a:r>
+              <a:rPr lang="en-US" sz="3600" b="1" dirty="0">
+                <a:solidFill>
+                  <a:srgbClr val="FFFFFF"/>
                 </a:solidFill>
                 <a:latin typeface="Arial" pitchFamily="34" charset="0"/>
                 <a:ea typeface="Arial" pitchFamily="34" charset="-122"/>
                 <a:cs typeface="Arial" pitchFamily="34" charset="-120"/>
               </a:rPr>
-              <a:t>01  —  EL PLAN</a:t>
+              <a:t>TRES FASES, UN OBJETIVO</a:t>
+            </a:r>
+            <a:endParaRPr lang="en-US" sz="3600" dirty="0"/>
+          </a:p>
+        </p:txBody>
+      </p:sp>
+      <p:sp>
+        <p:nvSpPr>
+          <p:cNvPr id="4" name="Text 2"/>
+          <p:cNvSpPr/>
+          <p:nvPr/>
+        </p:nvSpPr>
+        <p:spPr>
+          <a:xfrm>
+            <a:off x="822960" y="1975104"/>
+            <a:ext cx="10545775" cy="292608"/>
+          </a:xfrm>
+          <a:prstGeom prst="rect">
+            <a:avLst/>
+          </a:prstGeom>
+          <a:noFill/>
+          <a:ln/>
+        </p:spPr>
+        <p:txBody>
+          <a:bodyPr wrap="square" lIns="0" tIns="0" rIns="0" bIns="0" rtlCol="0" anchor="ctr"/>
+          <a:lstStyle/>
+          <a:p>
+            <a:pPr indent="0" marL="0">
+              <a:buNone/>
+            </a:pPr>
+            <a:r>
+              <a:rPr lang="en-US" sz="1100" b="1" spc="100" kern="0" dirty="0">
+                <a:solidFill>
+                  <a:srgbClr val="BFA3C8"/>
+                </a:solidFill>
+                <a:latin typeface="Courier New" pitchFamily="34" charset="0"/>
+                <a:ea typeface="Courier New" pitchFamily="34" charset="-122"/>
+                <a:cs typeface="Courier New" pitchFamily="34" charset="-120"/>
+              </a:rPr>
+              <a:t>CADA FASE CONSTRUYE LO QUE LA SIGUIENTE NECESITA.</a:t>
             </a:r>
             <a:endParaRPr lang="en-US" sz="1100" dirty="0"/>
           </a:p>
@@ -1542,53 +1624,53 @@
       </p:sp>
       <p:sp>
         <p:nvSpPr>
-          <p:cNvPr id="3" name="Text 1"/>
-          <p:cNvSpPr/>
-          <p:nvPr/>
-        </p:nvSpPr>
-        <p:spPr>
-          <a:xfrm>
-            <a:off x="822960" y="1133856"/>
-            <a:ext cx="10545775" cy="731520"/>
-          </a:xfrm>
-          <a:prstGeom prst="rect">
-            <a:avLst/>
-          </a:prstGeom>
-          <a:noFill/>
-          <a:ln/>
-        </p:spPr>
-        <p:txBody>
-          <a:bodyPr wrap="square" lIns="0" tIns="0" rIns="0" bIns="0" rtlCol="0" anchor="ctr"/>
-          <a:lstStyle/>
-          <a:p>
-            <a:pPr indent="0" marL="0">
-              <a:buNone/>
-            </a:pPr>
-            <a:r>
-              <a:rPr lang="en-US" sz="3800" b="1" dirty="0">
-                <a:solidFill>
-                  <a:srgbClr val="F2EEE9"/>
+          <p:cNvPr id="5" name="Text 3"/>
+          <p:cNvSpPr/>
+          <p:nvPr/>
+        </p:nvSpPr>
+        <p:spPr>
+          <a:xfrm>
+            <a:off x="822960" y="2670048"/>
+            <a:ext cx="3108960" cy="1051560"/>
+          </a:xfrm>
+          <a:prstGeom prst="rect">
+            <a:avLst/>
+          </a:prstGeom>
+          <a:noFill/>
+          <a:ln/>
+        </p:spPr>
+        <p:txBody>
+          <a:bodyPr wrap="square" lIns="0" tIns="0" rIns="0" bIns="0" rtlCol="0" anchor="t"/>
+          <a:lstStyle/>
+          <a:p>
+            <a:pPr indent="0" marL="0">
+              <a:buNone/>
+            </a:pPr>
+            <a:r>
+              <a:rPr lang="en-US" sz="7200" b="1" dirty="0">
+                <a:solidFill>
+                  <a:srgbClr val="DE27A0"/>
                 </a:solidFill>
                 <a:latin typeface="Arial" pitchFamily="34" charset="0"/>
                 <a:ea typeface="Arial" pitchFamily="34" charset="-122"/>
                 <a:cs typeface="Arial" pitchFamily="34" charset="-120"/>
               </a:rPr>
-              <a:t>Tres fases, un objetivo</a:t>
-            </a:r>
-            <a:endParaRPr lang="en-US" sz="3800" dirty="0"/>
-          </a:p>
-        </p:txBody>
-      </p:sp>
-      <p:sp>
-        <p:nvSpPr>
-          <p:cNvPr id="4" name="Text 2"/>
-          <p:cNvSpPr/>
-          <p:nvPr/>
-        </p:nvSpPr>
-        <p:spPr>
-          <a:xfrm>
-            <a:off x="822960" y="1901952"/>
-            <a:ext cx="10545775" cy="329184"/>
+              <a:t>1</a:t>
+            </a:r>
+            <a:endParaRPr lang="en-US" sz="7200" dirty="0"/>
+          </a:p>
+        </p:txBody>
+      </p:sp>
+      <p:sp>
+        <p:nvSpPr>
+          <p:cNvPr id="6" name="Text 4"/>
+          <p:cNvSpPr/>
+          <p:nvPr/>
+        </p:nvSpPr>
+        <p:spPr>
+          <a:xfrm>
+            <a:off x="822960" y="3822192"/>
+            <a:ext cx="3108960" cy="256032"/>
           </a:xfrm>
           <a:prstGeom prst="rect">
             <a:avLst/>
@@ -1604,30 +1686,30 @@
               <a:buNone/>
             </a:pPr>
             <a:r>
-              <a:rPr lang="en-US" sz="1500" dirty="0">
-                <a:solidFill>
-                  <a:srgbClr val="8A807A"/>
-                </a:solidFill>
-                <a:latin typeface="Calibri" pitchFamily="34" charset="0"/>
-                <a:ea typeface="Calibri" pitchFamily="34" charset="-122"/>
-                <a:cs typeface="Calibri" pitchFamily="34" charset="-120"/>
-              </a:rPr>
-              <a:t>Cada fase construye lo que la siguiente necesita.</a:t>
-            </a:r>
-            <a:endParaRPr lang="en-US" sz="1500" dirty="0"/>
-          </a:p>
-        </p:txBody>
-      </p:sp>
-      <p:sp>
-        <p:nvSpPr>
-          <p:cNvPr id="5" name="Text 3"/>
-          <p:cNvSpPr/>
-          <p:nvPr/>
-        </p:nvSpPr>
-        <p:spPr>
-          <a:xfrm>
-            <a:off x="822960" y="2606040"/>
-            <a:ext cx="3108960" cy="1051560"/>
+              <a:rPr lang="en-US" sz="1100" b="1" spc="300" kern="0" dirty="0">
+                <a:solidFill>
+                  <a:srgbClr val="DE27A0"/>
+                </a:solidFill>
+                <a:latin typeface="Courier New" pitchFamily="34" charset="0"/>
+                <a:ea typeface="Courier New" pitchFamily="34" charset="-122"/>
+                <a:cs typeface="Courier New" pitchFamily="34" charset="-120"/>
+              </a:rPr>
+              <a:t>META</a:t>
+            </a:r>
+            <a:endParaRPr lang="en-US" sz="1100" dirty="0"/>
+          </a:p>
+        </p:txBody>
+      </p:sp>
+      <p:sp>
+        <p:nvSpPr>
+          <p:cNvPr id="7" name="Text 5"/>
+          <p:cNvSpPr/>
+          <p:nvPr/>
+        </p:nvSpPr>
+        <p:spPr>
+          <a:xfrm>
+            <a:off x="822960" y="4151376"/>
+            <a:ext cx="3108960" cy="1005840"/>
           </a:xfrm>
           <a:prstGeom prst="rect">
             <a:avLst/>
@@ -1640,72 +1722,176 @@
           <a:lstStyle/>
           <a:p>
             <a:pPr indent="0" marL="0">
-              <a:buNone/>
-            </a:pPr>
-            <a:r>
-              <a:rPr lang="en-US" sz="7200" b="1" dirty="0">
-                <a:solidFill>
-                  <a:srgbClr val="EF5B25"/>
+              <a:lnSpc>
+                <a:spcPct val="105000"/>
+              </a:lnSpc>
+              <a:buNone/>
+            </a:pPr>
+            <a:r>
+              <a:rPr lang="en-US" sz="2300" b="1" dirty="0">
+                <a:solidFill>
+                  <a:srgbClr val="FFFFFF"/>
                 </a:solidFill>
                 <a:latin typeface="Arial" pitchFamily="34" charset="0"/>
                 <a:ea typeface="Arial" pitchFamily="34" charset="-122"/>
                 <a:cs typeface="Arial" pitchFamily="34" charset="-120"/>
               </a:rPr>
-              <a:t>1</a:t>
-            </a:r>
-            <a:endParaRPr lang="en-US" sz="7200" dirty="0"/>
-          </a:p>
-        </p:txBody>
-      </p:sp>
-      <p:sp>
-        <p:nvSpPr>
-          <p:cNvPr id="6" name="Text 4"/>
-          <p:cNvSpPr/>
-          <p:nvPr/>
-        </p:nvSpPr>
-        <p:spPr>
-          <a:xfrm>
-            <a:off x="822960" y="3767328"/>
-            <a:ext cx="3108960" cy="256032"/>
-          </a:xfrm>
-          <a:prstGeom prst="rect">
-            <a:avLst/>
-          </a:prstGeom>
-          <a:noFill/>
-          <a:ln/>
-        </p:spPr>
-        <p:txBody>
-          <a:bodyPr wrap="square" lIns="0" tIns="0" rIns="0" bIns="0" rtlCol="0" anchor="ctr"/>
-          <a:lstStyle/>
-          <a:p>
-            <a:pPr indent="0" marL="0">
-              <a:buNone/>
-            </a:pPr>
-            <a:r>
-              <a:rPr lang="en-US" sz="1050" b="1" spc="250" kern="0" dirty="0">
-                <a:solidFill>
-                  <a:srgbClr val="8A807A"/>
+              <a:t>QUE NOS</a:t>
+            </a:r>
+            <a:endParaRPr lang="en-US" sz="2300" dirty="0"/>
+          </a:p>
+          <a:p>
+            <a:pPr indent="0" marL="0">
+              <a:lnSpc>
+                <a:spcPct val="105000"/>
+              </a:lnSpc>
+              <a:buNone/>
+            </a:pPr>
+            <a:r>
+              <a:rPr lang="en-US" sz="2300" b="1" dirty="0">
+                <a:solidFill>
+                  <a:srgbClr val="FFFFFF"/>
                 </a:solidFill>
                 <a:latin typeface="Arial" pitchFamily="34" charset="0"/>
                 <a:ea typeface="Arial" pitchFamily="34" charset="-122"/>
                 <a:cs typeface="Arial" pitchFamily="34" charset="-120"/>
               </a:rPr>
+              <a:t>CONOZCAN</a:t>
+            </a:r>
+            <a:endParaRPr lang="en-US" sz="2300" dirty="0"/>
+          </a:p>
+        </p:txBody>
+      </p:sp>
+      <p:sp>
+        <p:nvSpPr>
+          <p:cNvPr id="8" name="Text 6"/>
+          <p:cNvSpPr/>
+          <p:nvPr/>
+        </p:nvSpPr>
+        <p:spPr>
+          <a:xfrm>
+            <a:off x="822960" y="5285232"/>
+            <a:ext cx="3108960" cy="822960"/>
+          </a:xfrm>
+          <a:prstGeom prst="rect">
+            <a:avLst/>
+          </a:prstGeom>
+          <a:noFill/>
+          <a:ln/>
+        </p:spPr>
+        <p:txBody>
+          <a:bodyPr wrap="square" lIns="0" tIns="0" rIns="0" bIns="0" rtlCol="0" anchor="t"/>
+          <a:lstStyle/>
+          <a:p>
+            <a:pPr indent="0" marL="0">
+              <a:lnSpc>
+                <a:spcPct val="130000"/>
+              </a:lnSpc>
+              <a:buNone/>
+            </a:pPr>
+            <a:r>
+              <a:rPr lang="en-US" sz="1100" b="1" spc="50" kern="0" dirty="0">
+                <a:solidFill>
+                  <a:srgbClr val="BFA3C8"/>
+                </a:solidFill>
+                <a:latin typeface="Courier New" pitchFamily="34" charset="0"/>
+                <a:ea typeface="Courier New" pitchFamily="34" charset="-122"/>
+                <a:cs typeface="Courier New" pitchFamily="34" charset="-120"/>
+              </a:rPr>
+              <a:t>INSTALAMOS LA MARCA Y DEJAMOS LA MEDICIÓN ANDANDO.</a:t>
+            </a:r>
+            <a:endParaRPr lang="en-US" sz="1100" dirty="0"/>
+          </a:p>
+        </p:txBody>
+      </p:sp>
+      <p:sp>
+        <p:nvSpPr>
+          <p:cNvPr id="9" name="Text 7"/>
+          <p:cNvSpPr/>
+          <p:nvPr/>
+        </p:nvSpPr>
+        <p:spPr>
+          <a:xfrm>
+            <a:off x="4541368" y="2670048"/>
+            <a:ext cx="3108960" cy="1051560"/>
+          </a:xfrm>
+          <a:prstGeom prst="rect">
+            <a:avLst/>
+          </a:prstGeom>
+          <a:noFill/>
+          <a:ln/>
+        </p:spPr>
+        <p:txBody>
+          <a:bodyPr wrap="square" lIns="0" tIns="0" rIns="0" bIns="0" rtlCol="0" anchor="t"/>
+          <a:lstStyle/>
+          <a:p>
+            <a:pPr indent="0" marL="0">
+              <a:buNone/>
+            </a:pPr>
+            <a:r>
+              <a:rPr lang="en-US" sz="7200" b="1" dirty="0">
+                <a:solidFill>
+                  <a:srgbClr val="DE27A0"/>
+                </a:solidFill>
+                <a:latin typeface="Arial" pitchFamily="34" charset="0"/>
+                <a:ea typeface="Arial" pitchFamily="34" charset="-122"/>
+                <a:cs typeface="Arial" pitchFamily="34" charset="-120"/>
+              </a:rPr>
+              <a:t>2</a:t>
+            </a:r>
+            <a:endParaRPr lang="en-US" sz="7200" dirty="0"/>
+          </a:p>
+        </p:txBody>
+      </p:sp>
+      <p:sp>
+        <p:nvSpPr>
+          <p:cNvPr id="10" name="Text 8"/>
+          <p:cNvSpPr/>
+          <p:nvPr/>
+        </p:nvSpPr>
+        <p:spPr>
+          <a:xfrm>
+            <a:off x="4541368" y="3822192"/>
+            <a:ext cx="3108960" cy="256032"/>
+          </a:xfrm>
+          <a:prstGeom prst="rect">
+            <a:avLst/>
+          </a:prstGeom>
+          <a:noFill/>
+          <a:ln/>
+        </p:spPr>
+        <p:txBody>
+          <a:bodyPr wrap="square" lIns="0" tIns="0" rIns="0" bIns="0" rtlCol="0" anchor="ctr"/>
+          <a:lstStyle/>
+          <a:p>
+            <a:pPr indent="0" marL="0">
+              <a:buNone/>
+            </a:pPr>
+            <a:r>
+              <a:rPr lang="en-US" sz="1100" b="1" spc="300" kern="0" dirty="0">
+                <a:solidFill>
+                  <a:srgbClr val="DE27A0"/>
+                </a:solidFill>
+                <a:latin typeface="Courier New" pitchFamily="34" charset="0"/>
+                <a:ea typeface="Courier New" pitchFamily="34" charset="-122"/>
+                <a:cs typeface="Courier New" pitchFamily="34" charset="-120"/>
+              </a:rPr>
               <a:t>META</a:t>
             </a:r>
-            <a:endParaRPr lang="en-US" sz="1050" dirty="0"/>
-          </a:p>
-        </p:txBody>
-      </p:sp>
-      <p:sp>
-        <p:nvSpPr>
-          <p:cNvPr id="7" name="Text 5"/>
-          <p:cNvSpPr/>
-          <p:nvPr/>
-        </p:nvSpPr>
-        <p:spPr>
-          <a:xfrm>
-            <a:off x="822960" y="4078224"/>
-            <a:ext cx="3108960" cy="1051560"/>
+            <a:endParaRPr lang="en-US" sz="1100" dirty="0"/>
+          </a:p>
+        </p:txBody>
+      </p:sp>
+      <p:sp>
+        <p:nvSpPr>
+          <p:cNvPr id="11" name="Text 9"/>
+          <p:cNvSpPr/>
+          <p:nvPr/>
+        </p:nvSpPr>
+        <p:spPr>
+          <a:xfrm>
+            <a:off x="4541368" y="4151376"/>
+            <a:ext cx="3108960" cy="1005840"/>
           </a:xfrm>
           <a:prstGeom prst="rect">
             <a:avLst/>
@@ -1724,17 +1910,17 @@
               <a:buNone/>
             </a:pPr>
             <a:r>
-              <a:rPr lang="en-US" sz="2500" b="1" dirty="0">
-                <a:solidFill>
-                  <a:srgbClr val="F2EEE9"/>
+              <a:rPr lang="en-US" sz="2300" b="1" dirty="0">
+                <a:solidFill>
+                  <a:srgbClr val="FFFFFF"/>
                 </a:solidFill>
                 <a:latin typeface="Arial" pitchFamily="34" charset="0"/>
                 <a:ea typeface="Arial" pitchFamily="34" charset="-122"/>
                 <a:cs typeface="Arial" pitchFamily="34" charset="-120"/>
               </a:rPr>
-              <a:t>Que nos</a:t>
-            </a:r>
-            <a:endParaRPr lang="en-US" sz="2500" dirty="0"/>
+              <a:t>QUE</a:t>
+            </a:r>
+            <a:endParaRPr lang="en-US" sz="2300" dirty="0"/>
           </a:p>
           <a:p>
             <a:pPr indent="0" marL="0">
@@ -1744,30 +1930,30 @@
               <a:buNone/>
             </a:pPr>
             <a:r>
-              <a:rPr lang="en-US" sz="2500" b="1" dirty="0">
-                <a:solidFill>
-                  <a:srgbClr val="F2EEE9"/>
+              <a:rPr lang="en-US" sz="2300" b="1" dirty="0">
+                <a:solidFill>
+                  <a:srgbClr val="FFFFFF"/>
                 </a:solidFill>
                 <a:latin typeface="Arial" pitchFamily="34" charset="0"/>
                 <a:ea typeface="Arial" pitchFamily="34" charset="-122"/>
                 <a:cs typeface="Arial" pitchFamily="34" charset="-120"/>
               </a:rPr>
-              <a:t>conozcan</a:t>
-            </a:r>
-            <a:endParaRPr lang="en-US" sz="2500" dirty="0"/>
-          </a:p>
-        </p:txBody>
-      </p:sp>
-      <p:sp>
-        <p:nvSpPr>
-          <p:cNvPr id="8" name="Text 6"/>
-          <p:cNvSpPr/>
-          <p:nvPr/>
-        </p:nvSpPr>
-        <p:spPr>
-          <a:xfrm>
-            <a:off x="822960" y="5230368"/>
-            <a:ext cx="3108960" cy="777240"/>
+              <a:t>COMPREN</a:t>
+            </a:r>
+            <a:endParaRPr lang="en-US" sz="2300" dirty="0"/>
+          </a:p>
+        </p:txBody>
+      </p:sp>
+      <p:sp>
+        <p:nvSpPr>
+          <p:cNvPr id="12" name="Text 10"/>
+          <p:cNvSpPr/>
+          <p:nvPr/>
+        </p:nvSpPr>
+        <p:spPr>
+          <a:xfrm>
+            <a:off x="4541368" y="5285232"/>
+            <a:ext cx="3108960" cy="822960"/>
           </a:xfrm>
           <a:prstGeom prst="rect">
             <a:avLst/>
@@ -1781,34 +1967,34 @@
           <a:p>
             <a:pPr indent="0" marL="0">
               <a:lnSpc>
-                <a:spcPct val="115000"/>
+                <a:spcPct val="130000"/>
               </a:lnSpc>
               <a:buNone/>
             </a:pPr>
             <a:r>
-              <a:rPr lang="en-US" sz="1400" dirty="0">
-                <a:solidFill>
-                  <a:srgbClr val="8A807A"/>
-                </a:solidFill>
-                <a:latin typeface="Calibri" pitchFamily="34" charset="0"/>
-                <a:ea typeface="Calibri" pitchFamily="34" charset="-122"/>
-                <a:cs typeface="Calibri" pitchFamily="34" charset="-120"/>
-              </a:rPr>
-              <a:t>Instalamos la marca y dejamos la medición andando.</a:t>
-            </a:r>
-            <a:endParaRPr lang="en-US" sz="1400" dirty="0"/>
-          </a:p>
-        </p:txBody>
-      </p:sp>
-      <p:sp>
-        <p:nvSpPr>
-          <p:cNvPr id="9" name="Text 7"/>
-          <p:cNvSpPr/>
-          <p:nvPr/>
-        </p:nvSpPr>
-        <p:spPr>
-          <a:xfrm>
-            <a:off x="4541368" y="2606040"/>
+              <a:rPr lang="en-US" sz="1100" b="1" spc="50" kern="0" dirty="0">
+                <a:solidFill>
+                  <a:srgbClr val="BFA3C8"/>
+                </a:solidFill>
+                <a:latin typeface="Courier New" pitchFamily="34" charset="0"/>
+                <a:ea typeface="Courier New" pitchFamily="34" charset="-122"/>
+                <a:cs typeface="Courier New" pitchFamily="34" charset="-120"/>
+              </a:rPr>
+              <a:t>CAMPAÑAS DE VENTA DIRECTA AL ECOMMERCE.</a:t>
+            </a:r>
+            <a:endParaRPr lang="en-US" sz="1100" dirty="0"/>
+          </a:p>
+        </p:txBody>
+      </p:sp>
+      <p:sp>
+        <p:nvSpPr>
+          <p:cNvPr id="13" name="Text 11"/>
+          <p:cNvSpPr/>
+          <p:nvPr/>
+        </p:nvSpPr>
+        <p:spPr>
+          <a:xfrm>
+            <a:off x="8259775" y="2670048"/>
             <a:ext cx="3108960" cy="1051560"/>
           </a:xfrm>
           <a:prstGeom prst="rect">
@@ -1827,13 +2013,13 @@
             <a:r>
               <a:rPr lang="en-US" sz="7200" b="1" dirty="0">
                 <a:solidFill>
-                  <a:srgbClr val="EF5B25"/>
+                  <a:srgbClr val="DE27A0"/>
                 </a:solidFill>
                 <a:latin typeface="Arial" pitchFamily="34" charset="0"/>
                 <a:ea typeface="Arial" pitchFamily="34" charset="-122"/>
                 <a:cs typeface="Arial" pitchFamily="34" charset="-120"/>
               </a:rPr>
-              <a:t>2</a:t>
+              <a:t>3</a:t>
             </a:r>
             <a:endParaRPr lang="en-US" sz="7200" dirty="0"/>
           </a:p>
@@ -1841,13 +2027,13 @@
       </p:sp>
       <p:sp>
         <p:nvSpPr>
-          <p:cNvPr id="10" name="Text 8"/>
-          <p:cNvSpPr/>
-          <p:nvPr/>
-        </p:nvSpPr>
-        <p:spPr>
-          <a:xfrm>
-            <a:off x="4541368" y="3767328"/>
+          <p:cNvPr id="14" name="Text 12"/>
+          <p:cNvSpPr/>
+          <p:nvPr/>
+        </p:nvSpPr>
+        <p:spPr>
+          <a:xfrm>
+            <a:off x="8259775" y="3822192"/>
             <a:ext cx="3108960" cy="256032"/>
           </a:xfrm>
           <a:prstGeom prst="rect">
@@ -1864,40 +2050,60 @@
               <a:buNone/>
             </a:pPr>
             <a:r>
-              <a:rPr lang="en-US" sz="1050" b="1" spc="250" kern="0" dirty="0">
-                <a:solidFill>
-                  <a:srgbClr val="8A807A"/>
+              <a:rPr lang="en-US" sz="1100" b="1" spc="300" kern="0" dirty="0">
+                <a:solidFill>
+                  <a:srgbClr val="DE27A0"/>
+                </a:solidFill>
+                <a:latin typeface="Courier New" pitchFamily="34" charset="0"/>
+                <a:ea typeface="Courier New" pitchFamily="34" charset="-122"/>
+                <a:cs typeface="Courier New" pitchFamily="34" charset="-120"/>
+              </a:rPr>
+              <a:t>GOOGLE</a:t>
+            </a:r>
+            <a:endParaRPr lang="en-US" sz="1100" dirty="0"/>
+          </a:p>
+        </p:txBody>
+      </p:sp>
+      <p:sp>
+        <p:nvSpPr>
+          <p:cNvPr id="15" name="Text 13"/>
+          <p:cNvSpPr/>
+          <p:nvPr/>
+        </p:nvSpPr>
+        <p:spPr>
+          <a:xfrm>
+            <a:off x="8259775" y="4151376"/>
+            <a:ext cx="3108960" cy="1005840"/>
+          </a:xfrm>
+          <a:prstGeom prst="rect">
+            <a:avLst/>
+          </a:prstGeom>
+          <a:noFill/>
+          <a:ln/>
+        </p:spPr>
+        <p:txBody>
+          <a:bodyPr wrap="square" lIns="0" tIns="0" rIns="0" bIns="0" rtlCol="0" anchor="t"/>
+          <a:lstStyle/>
+          <a:p>
+            <a:pPr indent="0" marL="0">
+              <a:lnSpc>
+                <a:spcPct val="105000"/>
+              </a:lnSpc>
+              <a:buNone/>
+            </a:pPr>
+            <a:r>
+              <a:rPr lang="en-US" sz="2300" b="1" dirty="0">
+                <a:solidFill>
+                  <a:srgbClr val="FFFFFF"/>
                 </a:solidFill>
                 <a:latin typeface="Arial" pitchFamily="34" charset="0"/>
                 <a:ea typeface="Arial" pitchFamily="34" charset="-122"/>
                 <a:cs typeface="Arial" pitchFamily="34" charset="-120"/>
               </a:rPr>
-              <a:t>META</a:t>
-            </a:r>
-            <a:endParaRPr lang="en-US" sz="1050" dirty="0"/>
-          </a:p>
-        </p:txBody>
-      </p:sp>
-      <p:sp>
-        <p:nvSpPr>
-          <p:cNvPr id="11" name="Text 9"/>
-          <p:cNvSpPr/>
-          <p:nvPr/>
-        </p:nvSpPr>
-        <p:spPr>
-          <a:xfrm>
-            <a:off x="4541368" y="4078224"/>
-            <a:ext cx="3108960" cy="1051560"/>
-          </a:xfrm>
-          <a:prstGeom prst="rect">
-            <a:avLst/>
-          </a:prstGeom>
-          <a:noFill/>
-          <a:ln/>
-        </p:spPr>
-        <p:txBody>
-          <a:bodyPr wrap="square" lIns="0" tIns="0" rIns="0" bIns="0" rtlCol="0" anchor="t"/>
-          <a:lstStyle/>
+              <a:t>QUE NOS</a:t>
+            </a:r>
+            <a:endParaRPr lang="en-US" sz="2300" dirty="0"/>
+          </a:p>
           <a:p>
             <a:pPr indent="0" marL="0">
               <a:lnSpc>
@@ -1906,261 +2112,59 @@
               <a:buNone/>
             </a:pPr>
             <a:r>
-              <a:rPr lang="en-US" sz="2500" b="1" dirty="0">
-                <a:solidFill>
-                  <a:srgbClr val="F2EEE9"/>
+              <a:rPr lang="en-US" sz="2300" b="1" dirty="0">
+                <a:solidFill>
+                  <a:srgbClr val="FFFFFF"/>
                 </a:solidFill>
                 <a:latin typeface="Arial" pitchFamily="34" charset="0"/>
                 <a:ea typeface="Arial" pitchFamily="34" charset="-122"/>
                 <a:cs typeface="Arial" pitchFamily="34" charset="-120"/>
               </a:rPr>
-              <a:t>Que</a:t>
-            </a:r>
-            <a:endParaRPr lang="en-US" sz="2500" dirty="0"/>
-          </a:p>
+              <a:t>ENCUENTREN</a:t>
+            </a:r>
+            <a:endParaRPr lang="en-US" sz="2300" dirty="0"/>
+          </a:p>
+        </p:txBody>
+      </p:sp>
+      <p:sp>
+        <p:nvSpPr>
+          <p:cNvPr id="16" name="Text 14"/>
+          <p:cNvSpPr/>
+          <p:nvPr/>
+        </p:nvSpPr>
+        <p:spPr>
+          <a:xfrm>
+            <a:off x="8259775" y="5285232"/>
+            <a:ext cx="3108960" cy="822960"/>
+          </a:xfrm>
+          <a:prstGeom prst="rect">
+            <a:avLst/>
+          </a:prstGeom>
+          <a:noFill/>
+          <a:ln/>
+        </p:spPr>
+        <p:txBody>
+          <a:bodyPr wrap="square" lIns="0" tIns="0" rIns="0" bIns="0" rtlCol="0" anchor="t"/>
+          <a:lstStyle/>
           <a:p>
             <a:pPr indent="0" marL="0">
               <a:lnSpc>
-                <a:spcPct val="105000"/>
+                <a:spcPct val="130000"/>
               </a:lnSpc>
               <a:buNone/>
             </a:pPr>
             <a:r>
-              <a:rPr lang="en-US" sz="2500" b="1" dirty="0">
-                <a:solidFill>
-                  <a:srgbClr val="F2EEE9"/>
-                </a:solidFill>
-                <a:latin typeface="Arial" pitchFamily="34" charset="0"/>
-                <a:ea typeface="Arial" pitchFamily="34" charset="-122"/>
-                <a:cs typeface="Arial" pitchFamily="34" charset="-120"/>
-              </a:rPr>
-              <a:t>compren</a:t>
-            </a:r>
-            <a:endParaRPr lang="en-US" sz="2500" dirty="0"/>
-          </a:p>
-        </p:txBody>
-      </p:sp>
-      <p:sp>
-        <p:nvSpPr>
-          <p:cNvPr id="12" name="Text 10"/>
-          <p:cNvSpPr/>
-          <p:nvPr/>
-        </p:nvSpPr>
-        <p:spPr>
-          <a:xfrm>
-            <a:off x="4541368" y="5230368"/>
-            <a:ext cx="3108960" cy="777240"/>
-          </a:xfrm>
-          <a:prstGeom prst="rect">
-            <a:avLst/>
-          </a:prstGeom>
-          <a:noFill/>
-          <a:ln/>
-        </p:spPr>
-        <p:txBody>
-          <a:bodyPr wrap="square" lIns="0" tIns="0" rIns="0" bIns="0" rtlCol="0" anchor="t"/>
-          <a:lstStyle/>
-          <a:p>
-            <a:pPr indent="0" marL="0">
-              <a:lnSpc>
-                <a:spcPct val="115000"/>
-              </a:lnSpc>
-              <a:buNone/>
-            </a:pPr>
-            <a:r>
-              <a:rPr lang="en-US" sz="1400" dirty="0">
-                <a:solidFill>
-                  <a:srgbClr val="8A807A"/>
-                </a:solidFill>
-                <a:latin typeface="Calibri" pitchFamily="34" charset="0"/>
-                <a:ea typeface="Calibri" pitchFamily="34" charset="-122"/>
-                <a:cs typeface="Calibri" pitchFamily="34" charset="-120"/>
-              </a:rPr>
-              <a:t>Campañas de venta directa al ecommerce.</a:t>
-            </a:r>
-            <a:endParaRPr lang="en-US" sz="1400" dirty="0"/>
-          </a:p>
-        </p:txBody>
-      </p:sp>
-      <p:sp>
-        <p:nvSpPr>
-          <p:cNvPr id="13" name="Text 11"/>
-          <p:cNvSpPr/>
-          <p:nvPr/>
-        </p:nvSpPr>
-        <p:spPr>
-          <a:xfrm>
-            <a:off x="8259775" y="2606040"/>
-            <a:ext cx="3108960" cy="1051560"/>
-          </a:xfrm>
-          <a:prstGeom prst="rect">
-            <a:avLst/>
-          </a:prstGeom>
-          <a:noFill/>
-          <a:ln/>
-        </p:spPr>
-        <p:txBody>
-          <a:bodyPr wrap="square" lIns="0" tIns="0" rIns="0" bIns="0" rtlCol="0" anchor="t"/>
-          <a:lstStyle/>
-          <a:p>
-            <a:pPr indent="0" marL="0">
-              <a:buNone/>
-            </a:pPr>
-            <a:r>
-              <a:rPr lang="en-US" sz="7200" b="1" dirty="0">
-                <a:solidFill>
-                  <a:srgbClr val="EF5B25"/>
-                </a:solidFill>
-                <a:latin typeface="Arial" pitchFamily="34" charset="0"/>
-                <a:ea typeface="Arial" pitchFamily="34" charset="-122"/>
-                <a:cs typeface="Arial" pitchFamily="34" charset="-120"/>
-              </a:rPr>
-              <a:t>3</a:t>
-            </a:r>
-            <a:endParaRPr lang="en-US" sz="7200" dirty="0"/>
-          </a:p>
-        </p:txBody>
-      </p:sp>
-      <p:sp>
-        <p:nvSpPr>
-          <p:cNvPr id="14" name="Text 12"/>
-          <p:cNvSpPr/>
-          <p:nvPr/>
-        </p:nvSpPr>
-        <p:spPr>
-          <a:xfrm>
-            <a:off x="8259775" y="3767328"/>
-            <a:ext cx="3108960" cy="256032"/>
-          </a:xfrm>
-          <a:prstGeom prst="rect">
-            <a:avLst/>
-          </a:prstGeom>
-          <a:noFill/>
-          <a:ln/>
-        </p:spPr>
-        <p:txBody>
-          <a:bodyPr wrap="square" lIns="0" tIns="0" rIns="0" bIns="0" rtlCol="0" anchor="ctr"/>
-          <a:lstStyle/>
-          <a:p>
-            <a:pPr indent="0" marL="0">
-              <a:buNone/>
-            </a:pPr>
-            <a:r>
-              <a:rPr lang="en-US" sz="1050" b="1" spc="250" kern="0" dirty="0">
-                <a:solidFill>
-                  <a:srgbClr val="8A807A"/>
-                </a:solidFill>
-                <a:latin typeface="Arial" pitchFamily="34" charset="0"/>
-                <a:ea typeface="Arial" pitchFamily="34" charset="-122"/>
-                <a:cs typeface="Arial" pitchFamily="34" charset="-120"/>
-              </a:rPr>
-              <a:t>GOOGLE</a:t>
-            </a:r>
-            <a:endParaRPr lang="en-US" sz="1050" dirty="0"/>
-          </a:p>
-        </p:txBody>
-      </p:sp>
-      <p:sp>
-        <p:nvSpPr>
-          <p:cNvPr id="15" name="Text 13"/>
-          <p:cNvSpPr/>
-          <p:nvPr/>
-        </p:nvSpPr>
-        <p:spPr>
-          <a:xfrm>
-            <a:off x="8259775" y="4078224"/>
-            <a:ext cx="3108960" cy="1051560"/>
-          </a:xfrm>
-          <a:prstGeom prst="rect">
-            <a:avLst/>
-          </a:prstGeom>
-          <a:noFill/>
-          <a:ln/>
-        </p:spPr>
-        <p:txBody>
-          <a:bodyPr wrap="square" lIns="0" tIns="0" rIns="0" bIns="0" rtlCol="0" anchor="t"/>
-          <a:lstStyle/>
-          <a:p>
-            <a:pPr indent="0" marL="0">
-              <a:lnSpc>
-                <a:spcPct val="105000"/>
-              </a:lnSpc>
-              <a:buNone/>
-            </a:pPr>
-            <a:r>
-              <a:rPr lang="en-US" sz="2500" b="1" dirty="0">
-                <a:solidFill>
-                  <a:srgbClr val="F2EEE9"/>
-                </a:solidFill>
-                <a:latin typeface="Arial" pitchFamily="34" charset="0"/>
-                <a:ea typeface="Arial" pitchFamily="34" charset="-122"/>
-                <a:cs typeface="Arial" pitchFamily="34" charset="-120"/>
-              </a:rPr>
-              <a:t>Que nos</a:t>
-            </a:r>
-            <a:endParaRPr lang="en-US" sz="2500" dirty="0"/>
-          </a:p>
-          <a:p>
-            <a:pPr indent="0" marL="0">
-              <a:lnSpc>
-                <a:spcPct val="105000"/>
-              </a:lnSpc>
-              <a:buNone/>
-            </a:pPr>
-            <a:r>
-              <a:rPr lang="en-US" sz="2500" b="1" dirty="0">
-                <a:solidFill>
-                  <a:srgbClr val="F2EEE9"/>
-                </a:solidFill>
-                <a:latin typeface="Arial" pitchFamily="34" charset="0"/>
-                <a:ea typeface="Arial" pitchFamily="34" charset="-122"/>
-                <a:cs typeface="Arial" pitchFamily="34" charset="-120"/>
-              </a:rPr>
-              <a:t>encuentren</a:t>
-            </a:r>
-            <a:endParaRPr lang="en-US" sz="2500" dirty="0"/>
-          </a:p>
-        </p:txBody>
-      </p:sp>
-      <p:sp>
-        <p:nvSpPr>
-          <p:cNvPr id="16" name="Text 14"/>
-          <p:cNvSpPr/>
-          <p:nvPr/>
-        </p:nvSpPr>
-        <p:spPr>
-          <a:xfrm>
-            <a:off x="8259775" y="5230368"/>
-            <a:ext cx="3108960" cy="777240"/>
-          </a:xfrm>
-          <a:prstGeom prst="rect">
-            <a:avLst/>
-          </a:prstGeom>
-          <a:noFill/>
-          <a:ln/>
-        </p:spPr>
-        <p:txBody>
-          <a:bodyPr wrap="square" lIns="0" tIns="0" rIns="0" bIns="0" rtlCol="0" anchor="t"/>
-          <a:lstStyle/>
-          <a:p>
-            <a:pPr indent="0" marL="0">
-              <a:lnSpc>
-                <a:spcPct val="115000"/>
-              </a:lnSpc>
-              <a:buNone/>
-            </a:pPr>
-            <a:r>
-              <a:rPr lang="en-US" sz="1400" dirty="0">
-                <a:solidFill>
-                  <a:srgbClr val="8A807A"/>
-                </a:solidFill>
-                <a:latin typeface="Calibri" pitchFamily="34" charset="0"/>
-                <a:ea typeface="Calibri" pitchFamily="34" charset="-122"/>
-                <a:cs typeface="Calibri" pitchFamily="34" charset="-120"/>
-              </a:rPr>
-              <a:t>Capturamos a quien ya está buscando vermut.</a:t>
-            </a:r>
-            <a:endParaRPr lang="en-US" sz="1400" dirty="0"/>
+              <a:rPr lang="en-US" sz="1100" b="1" spc="50" kern="0" dirty="0">
+                <a:solidFill>
+                  <a:srgbClr val="BFA3C8"/>
+                </a:solidFill>
+                <a:latin typeface="Courier New" pitchFamily="34" charset="0"/>
+                <a:ea typeface="Courier New" pitchFamily="34" charset="-122"/>
+                <a:cs typeface="Courier New" pitchFamily="34" charset="-120"/>
+              </a:rPr>
+              <a:t>CAPTURAMOS A QUIEN YA ESTÁ BUSCANDO VERMUT.</a:t>
+            </a:r>
+            <a:endParaRPr lang="en-US" sz="1100" dirty="0"/>
           </a:p>
         </p:txBody>
       </p:sp>
@@ -2178,7 +2182,7 @@
     <p:bg>
       <p:bgPr>
         <a:solidFill>
-          <a:srgbClr val="0F0E0D"/>
+          <a:srgbClr val="3A1842"/>
         </a:solidFill>
       </p:bgPr>
     </p:bg>
@@ -2221,30 +2225,69 @@
               <a:buNone/>
             </a:pPr>
             <a:r>
-              <a:rPr lang="en-US" sz="1100" b="1" spc="250" kern="0" dirty="0">
-                <a:solidFill>
-                  <a:srgbClr val="EF5B25"/>
+              <a:rPr lang="en-US" sz="1200" b="1" spc="200" kern="0" dirty="0">
+                <a:solidFill>
+                  <a:srgbClr val="DE27A0"/>
+                </a:solidFill>
+                <a:latin typeface="Courier New" pitchFamily="34" charset="0"/>
+                <a:ea typeface="Courier New" pitchFamily="34" charset="-122"/>
+                <a:cs typeface="Courier New" pitchFamily="34" charset="-120"/>
+              </a:rPr>
+              <a:t>02  —  MI TRABAJO</a:t>
+            </a:r>
+            <a:endParaRPr lang="en-US" sz="1200" dirty="0"/>
+          </a:p>
+        </p:txBody>
+      </p:sp>
+      <p:sp>
+        <p:nvSpPr>
+          <p:cNvPr id="3" name="Text 1"/>
+          <p:cNvSpPr/>
+          <p:nvPr/>
+        </p:nvSpPr>
+        <p:spPr>
+          <a:xfrm>
+            <a:off x="822960" y="1152144"/>
+            <a:ext cx="10545775" cy="731520"/>
+          </a:xfrm>
+          <a:prstGeom prst="rect">
+            <a:avLst/>
+          </a:prstGeom>
+          <a:noFill/>
+          <a:ln/>
+        </p:spPr>
+        <p:txBody>
+          <a:bodyPr wrap="square" lIns="0" tIns="0" rIns="0" bIns="0" rtlCol="0" anchor="ctr"/>
+          <a:lstStyle/>
+          <a:p>
+            <a:pPr indent="0" marL="0">
+              <a:buNone/>
+            </a:pPr>
+            <a:r>
+              <a:rPr lang="en-US" sz="3600" b="1" dirty="0">
+                <a:solidFill>
+                  <a:srgbClr val="FFFFFF"/>
                 </a:solidFill>
                 <a:latin typeface="Arial" pitchFamily="34" charset="0"/>
                 <a:ea typeface="Arial" pitchFamily="34" charset="-122"/>
                 <a:cs typeface="Arial" pitchFamily="34" charset="-120"/>
               </a:rPr>
-              <a:t>02  —  MI TRABAJO</a:t>
-            </a:r>
-            <a:endParaRPr lang="en-US" sz="1100" dirty="0"/>
-          </a:p>
-        </p:txBody>
-      </p:sp>
-      <p:sp>
-        <p:nvSpPr>
-          <p:cNvPr id="3" name="Text 1"/>
-          <p:cNvSpPr/>
-          <p:nvPr/>
-        </p:nvSpPr>
-        <p:spPr>
-          <a:xfrm>
-            <a:off x="822960" y="1133856"/>
-            <a:ext cx="10545775" cy="731520"/>
+              <a:t>QUÉ HAGO CADA MES</a:t>
+            </a:r>
+            <a:endParaRPr lang="en-US" sz="3600" dirty="0"/>
+          </a:p>
+        </p:txBody>
+      </p:sp>
+      <p:sp>
+        <p:nvSpPr>
+          <p:cNvPr id="4" name="Text 2"/>
+          <p:cNvSpPr/>
+          <p:nvPr/>
+        </p:nvSpPr>
+        <p:spPr>
+          <a:xfrm>
+            <a:off x="822960" y="2670048"/>
+            <a:ext cx="685800" cy="512064"/>
           </a:xfrm>
           <a:prstGeom prst="rect">
             <a:avLst/>
@@ -2260,30 +2303,30 @@
               <a:buNone/>
             </a:pPr>
             <a:r>
-              <a:rPr lang="en-US" sz="3800" b="1" dirty="0">
-                <a:solidFill>
-                  <a:srgbClr val="F2EEE9"/>
-                </a:solidFill>
-                <a:latin typeface="Arial" pitchFamily="34" charset="0"/>
-                <a:ea typeface="Arial" pitchFamily="34" charset="-122"/>
-                <a:cs typeface="Arial" pitchFamily="34" charset="-120"/>
-              </a:rPr>
-              <a:t>Qué hago cada mes</a:t>
-            </a:r>
-            <a:endParaRPr lang="en-US" sz="3800" dirty="0"/>
-          </a:p>
-        </p:txBody>
-      </p:sp>
-      <p:sp>
-        <p:nvSpPr>
-          <p:cNvPr id="4" name="Text 2"/>
-          <p:cNvSpPr/>
-          <p:nvPr/>
-        </p:nvSpPr>
-        <p:spPr>
-          <a:xfrm>
-            <a:off x="822960" y="2578608"/>
-            <a:ext cx="658368" cy="530352"/>
+              <a:rPr lang="en-US" sz="1500" b="1" spc="100" kern="0" dirty="0">
+                <a:solidFill>
+                  <a:srgbClr val="DE27A0"/>
+                </a:solidFill>
+                <a:latin typeface="Courier New" pitchFamily="34" charset="0"/>
+                <a:ea typeface="Courier New" pitchFamily="34" charset="-122"/>
+                <a:cs typeface="Courier New" pitchFamily="34" charset="-120"/>
+              </a:rPr>
+              <a:t>01</a:t>
+            </a:r>
+            <a:endParaRPr lang="en-US" sz="1500" dirty="0"/>
+          </a:p>
+        </p:txBody>
+      </p:sp>
+      <p:sp>
+        <p:nvSpPr>
+          <p:cNvPr id="5" name="Text 3"/>
+          <p:cNvSpPr/>
+          <p:nvPr/>
+        </p:nvSpPr>
+        <p:spPr>
+          <a:xfrm>
+            <a:off x="1719072" y="2670048"/>
+            <a:ext cx="9649663" cy="512064"/>
           </a:xfrm>
           <a:prstGeom prst="rect">
             <a:avLst/>
@@ -2299,30 +2342,30 @@
               <a:buNone/>
             </a:pPr>
             <a:r>
-              <a:rPr lang="en-US" sz="1600" b="1" dirty="0">
-                <a:solidFill>
-                  <a:srgbClr val="EF5B25"/>
-                </a:solidFill>
-                <a:latin typeface="Arial" pitchFamily="34" charset="0"/>
-                <a:ea typeface="Arial" pitchFamily="34" charset="-122"/>
-                <a:cs typeface="Arial" pitchFamily="34" charset="-120"/>
-              </a:rPr>
-              <a:t>01</a:t>
-            </a:r>
-            <a:endParaRPr lang="en-US" sz="1600" dirty="0"/>
-          </a:p>
-        </p:txBody>
-      </p:sp>
-      <p:sp>
-        <p:nvSpPr>
-          <p:cNvPr id="5" name="Text 3"/>
-          <p:cNvSpPr/>
-          <p:nvPr/>
-        </p:nvSpPr>
-        <p:spPr>
-          <a:xfrm>
-            <a:off x="1664208" y="2578608"/>
-            <a:ext cx="9704527" cy="530352"/>
+              <a:rPr lang="en-US" sz="1500" b="1" spc="80" kern="0" dirty="0">
+                <a:solidFill>
+                  <a:srgbClr val="FFFFFF"/>
+                </a:solidFill>
+                <a:latin typeface="Courier New" pitchFamily="34" charset="0"/>
+                <a:ea typeface="Courier New" pitchFamily="34" charset="-122"/>
+                <a:cs typeface="Courier New" pitchFamily="34" charset="-120"/>
+              </a:rPr>
+              <a:t>EL PLAN DE MEDIOS DEL MES</a:t>
+            </a:r>
+            <a:endParaRPr lang="en-US" sz="1500" dirty="0"/>
+          </a:p>
+        </p:txBody>
+      </p:sp>
+      <p:sp>
+        <p:nvSpPr>
+          <p:cNvPr id="6" name="Text 4"/>
+          <p:cNvSpPr/>
+          <p:nvPr/>
+        </p:nvSpPr>
+        <p:spPr>
+          <a:xfrm>
+            <a:off x="822960" y="3383280"/>
+            <a:ext cx="685800" cy="512064"/>
           </a:xfrm>
           <a:prstGeom prst="rect">
             <a:avLst/>
@@ -2338,30 +2381,30 @@
               <a:buNone/>
             </a:pPr>
             <a:r>
-              <a:rPr lang="en-US" sz="2100" dirty="0">
-                <a:solidFill>
-                  <a:srgbClr val="F2EEE9"/>
-                </a:solidFill>
-                <a:latin typeface="Calibri" pitchFamily="34" charset="0"/>
-                <a:ea typeface="Calibri" pitchFamily="34" charset="-122"/>
-                <a:cs typeface="Calibri" pitchFamily="34" charset="-120"/>
-              </a:rPr>
-              <a:t>El plan de medios del mes</a:t>
-            </a:r>
-            <a:endParaRPr lang="en-US" sz="2100" dirty="0"/>
-          </a:p>
-        </p:txBody>
-      </p:sp>
-      <p:sp>
-        <p:nvSpPr>
-          <p:cNvPr id="6" name="Text 4"/>
-          <p:cNvSpPr/>
-          <p:nvPr/>
-        </p:nvSpPr>
-        <p:spPr>
-          <a:xfrm>
-            <a:off x="822960" y="3310128"/>
-            <a:ext cx="658368" cy="530352"/>
+              <a:rPr lang="en-US" sz="1500" b="1" spc="100" kern="0" dirty="0">
+                <a:solidFill>
+                  <a:srgbClr val="DE27A0"/>
+                </a:solidFill>
+                <a:latin typeface="Courier New" pitchFamily="34" charset="0"/>
+                <a:ea typeface="Courier New" pitchFamily="34" charset="-122"/>
+                <a:cs typeface="Courier New" pitchFamily="34" charset="-120"/>
+              </a:rPr>
+              <a:t>02</a:t>
+            </a:r>
+            <a:endParaRPr lang="en-US" sz="1500" dirty="0"/>
+          </a:p>
+        </p:txBody>
+      </p:sp>
+      <p:sp>
+        <p:nvSpPr>
+          <p:cNvPr id="7" name="Text 5"/>
+          <p:cNvSpPr/>
+          <p:nvPr/>
+        </p:nvSpPr>
+        <p:spPr>
+          <a:xfrm>
+            <a:off x="1719072" y="3383280"/>
+            <a:ext cx="9649663" cy="512064"/>
           </a:xfrm>
           <a:prstGeom prst="rect">
             <a:avLst/>
@@ -2377,30 +2420,30 @@
               <a:buNone/>
             </a:pPr>
             <a:r>
-              <a:rPr lang="en-US" sz="1600" b="1" dirty="0">
-                <a:solidFill>
-                  <a:srgbClr val="EF5B25"/>
-                </a:solidFill>
-                <a:latin typeface="Arial" pitchFamily="34" charset="0"/>
-                <a:ea typeface="Arial" pitchFamily="34" charset="-122"/>
-                <a:cs typeface="Arial" pitchFamily="34" charset="-120"/>
-              </a:rPr>
-              <a:t>02</a:t>
-            </a:r>
-            <a:endParaRPr lang="en-US" sz="1600" dirty="0"/>
-          </a:p>
-        </p:txBody>
-      </p:sp>
-      <p:sp>
-        <p:nvSpPr>
-          <p:cNvPr id="7" name="Text 5"/>
-          <p:cNvSpPr/>
-          <p:nvPr/>
-        </p:nvSpPr>
-        <p:spPr>
-          <a:xfrm>
-            <a:off x="1664208" y="3310128"/>
-            <a:ext cx="9704527" cy="530352"/>
+              <a:rPr lang="en-US" sz="1500" b="1" spc="80" kern="0" dirty="0">
+                <a:solidFill>
+                  <a:srgbClr val="FFFFFF"/>
+                </a:solidFill>
+                <a:latin typeface="Courier New" pitchFamily="34" charset="0"/>
+                <a:ea typeface="Courier New" pitchFamily="34" charset="-122"/>
+                <a:cs typeface="Courier New" pitchFamily="34" charset="-120"/>
+              </a:rPr>
+              <a:t>EL REQUERIMIENTO DE CREATIVOS AL EQUIPO CREATIVO</a:t>
+            </a:r>
+            <a:endParaRPr lang="en-US" sz="1500" dirty="0"/>
+          </a:p>
+        </p:txBody>
+      </p:sp>
+      <p:sp>
+        <p:nvSpPr>
+          <p:cNvPr id="8" name="Text 6"/>
+          <p:cNvSpPr/>
+          <p:nvPr/>
+        </p:nvSpPr>
+        <p:spPr>
+          <a:xfrm>
+            <a:off x="822960" y="4096512"/>
+            <a:ext cx="685800" cy="512064"/>
           </a:xfrm>
           <a:prstGeom prst="rect">
             <a:avLst/>
@@ -2416,30 +2459,30 @@
               <a:buNone/>
             </a:pPr>
             <a:r>
-              <a:rPr lang="en-US" sz="2100" dirty="0">
-                <a:solidFill>
-                  <a:srgbClr val="F2EEE9"/>
-                </a:solidFill>
-                <a:latin typeface="Calibri" pitchFamily="34" charset="0"/>
-                <a:ea typeface="Calibri" pitchFamily="34" charset="-122"/>
-                <a:cs typeface="Calibri" pitchFamily="34" charset="-120"/>
-              </a:rPr>
-              <a:t>El requerimiento de creativos al equipo creativo</a:t>
-            </a:r>
-            <a:endParaRPr lang="en-US" sz="2100" dirty="0"/>
-          </a:p>
-        </p:txBody>
-      </p:sp>
-      <p:sp>
-        <p:nvSpPr>
-          <p:cNvPr id="8" name="Text 6"/>
-          <p:cNvSpPr/>
-          <p:nvPr/>
-        </p:nvSpPr>
-        <p:spPr>
-          <a:xfrm>
-            <a:off x="822960" y="4041648"/>
-            <a:ext cx="658368" cy="530352"/>
+              <a:rPr lang="en-US" sz="1500" b="1" spc="100" kern="0" dirty="0">
+                <a:solidFill>
+                  <a:srgbClr val="DE27A0"/>
+                </a:solidFill>
+                <a:latin typeface="Courier New" pitchFamily="34" charset="0"/>
+                <a:ea typeface="Courier New" pitchFamily="34" charset="-122"/>
+                <a:cs typeface="Courier New" pitchFamily="34" charset="-120"/>
+              </a:rPr>
+              <a:t>03</a:t>
+            </a:r>
+            <a:endParaRPr lang="en-US" sz="1500" dirty="0"/>
+          </a:p>
+        </p:txBody>
+      </p:sp>
+      <p:sp>
+        <p:nvSpPr>
+          <p:cNvPr id="9" name="Text 7"/>
+          <p:cNvSpPr/>
+          <p:nvPr/>
+        </p:nvSpPr>
+        <p:spPr>
+          <a:xfrm>
+            <a:off x="1719072" y="4096512"/>
+            <a:ext cx="9649663" cy="512064"/>
           </a:xfrm>
           <a:prstGeom prst="rect">
             <a:avLst/>
@@ -2455,30 +2498,30 @@
               <a:buNone/>
             </a:pPr>
             <a:r>
-              <a:rPr lang="en-US" sz="1600" b="1" dirty="0">
-                <a:solidFill>
-                  <a:srgbClr val="EF5B25"/>
-                </a:solidFill>
-                <a:latin typeface="Arial" pitchFamily="34" charset="0"/>
-                <a:ea typeface="Arial" pitchFamily="34" charset="-122"/>
-                <a:cs typeface="Arial" pitchFamily="34" charset="-120"/>
-              </a:rPr>
-              <a:t>03</a:t>
-            </a:r>
-            <a:endParaRPr lang="en-US" sz="1600" dirty="0"/>
-          </a:p>
-        </p:txBody>
-      </p:sp>
-      <p:sp>
-        <p:nvSpPr>
-          <p:cNvPr id="9" name="Text 7"/>
-          <p:cNvSpPr/>
-          <p:nvPr/>
-        </p:nvSpPr>
-        <p:spPr>
-          <a:xfrm>
-            <a:off x="1664208" y="4041648"/>
-            <a:ext cx="9704527" cy="530352"/>
+              <a:rPr lang="en-US" sz="1500" b="1" spc="80" kern="0" dirty="0">
+                <a:solidFill>
+                  <a:srgbClr val="FFFFFF"/>
+                </a:solidFill>
+                <a:latin typeface="Courier New" pitchFamily="34" charset="0"/>
+                <a:ea typeface="Courier New" pitchFamily="34" charset="-122"/>
+                <a:cs typeface="Courier New" pitchFamily="34" charset="-120"/>
+              </a:rPr>
+              <a:t>CONFIGURACIÓN DE CAMPAÑAS, PÍXEL Y CATÁLOGO</a:t>
+            </a:r>
+            <a:endParaRPr lang="en-US" sz="1500" dirty="0"/>
+          </a:p>
+        </p:txBody>
+      </p:sp>
+      <p:sp>
+        <p:nvSpPr>
+          <p:cNvPr id="10" name="Text 8"/>
+          <p:cNvSpPr/>
+          <p:nvPr/>
+        </p:nvSpPr>
+        <p:spPr>
+          <a:xfrm>
+            <a:off x="822960" y="4809744"/>
+            <a:ext cx="685800" cy="512064"/>
           </a:xfrm>
           <a:prstGeom prst="rect">
             <a:avLst/>
@@ -2494,30 +2537,30 @@
               <a:buNone/>
             </a:pPr>
             <a:r>
-              <a:rPr lang="en-US" sz="2100" dirty="0">
-                <a:solidFill>
-                  <a:srgbClr val="F2EEE9"/>
-                </a:solidFill>
-                <a:latin typeface="Calibri" pitchFamily="34" charset="0"/>
-                <a:ea typeface="Calibri" pitchFamily="34" charset="-122"/>
-                <a:cs typeface="Calibri" pitchFamily="34" charset="-120"/>
-              </a:rPr>
-              <a:t>Configuración de campañas, píxel y catálogo</a:t>
-            </a:r>
-            <a:endParaRPr lang="en-US" sz="2100" dirty="0"/>
-          </a:p>
-        </p:txBody>
-      </p:sp>
-      <p:sp>
-        <p:nvSpPr>
-          <p:cNvPr id="10" name="Text 8"/>
-          <p:cNvSpPr/>
-          <p:nvPr/>
-        </p:nvSpPr>
-        <p:spPr>
-          <a:xfrm>
-            <a:off x="822960" y="4773168"/>
-            <a:ext cx="658368" cy="530352"/>
+              <a:rPr lang="en-US" sz="1500" b="1" spc="100" kern="0" dirty="0">
+                <a:solidFill>
+                  <a:srgbClr val="DE27A0"/>
+                </a:solidFill>
+                <a:latin typeface="Courier New" pitchFamily="34" charset="0"/>
+                <a:ea typeface="Courier New" pitchFamily="34" charset="-122"/>
+                <a:cs typeface="Courier New" pitchFamily="34" charset="-120"/>
+              </a:rPr>
+              <a:t>04</a:t>
+            </a:r>
+            <a:endParaRPr lang="en-US" sz="1500" dirty="0"/>
+          </a:p>
+        </p:txBody>
+      </p:sp>
+      <p:sp>
+        <p:nvSpPr>
+          <p:cNvPr id="11" name="Text 9"/>
+          <p:cNvSpPr/>
+          <p:nvPr/>
+        </p:nvSpPr>
+        <p:spPr>
+          <a:xfrm>
+            <a:off x="1719072" y="4809744"/>
+            <a:ext cx="9649663" cy="512064"/>
           </a:xfrm>
           <a:prstGeom prst="rect">
             <a:avLst/>
@@ -2533,30 +2576,30 @@
               <a:buNone/>
             </a:pPr>
             <a:r>
-              <a:rPr lang="en-US" sz="1600" b="1" dirty="0">
-                <a:solidFill>
-                  <a:srgbClr val="EF5B25"/>
-                </a:solidFill>
-                <a:latin typeface="Arial" pitchFamily="34" charset="0"/>
-                <a:ea typeface="Arial" pitchFamily="34" charset="-122"/>
-                <a:cs typeface="Arial" pitchFamily="34" charset="-120"/>
-              </a:rPr>
-              <a:t>04</a:t>
-            </a:r>
-            <a:endParaRPr lang="en-US" sz="1600" dirty="0"/>
-          </a:p>
-        </p:txBody>
-      </p:sp>
-      <p:sp>
-        <p:nvSpPr>
-          <p:cNvPr id="11" name="Text 9"/>
-          <p:cNvSpPr/>
-          <p:nvPr/>
-        </p:nvSpPr>
-        <p:spPr>
-          <a:xfrm>
-            <a:off x="1664208" y="4773168"/>
-            <a:ext cx="9704527" cy="530352"/>
+              <a:rPr lang="en-US" sz="1500" b="1" spc="80" kern="0" dirty="0">
+                <a:solidFill>
+                  <a:srgbClr val="FFFFFF"/>
+                </a:solidFill>
+                <a:latin typeface="Courier New" pitchFamily="34" charset="0"/>
+                <a:ea typeface="Courier New" pitchFamily="34" charset="-122"/>
+                <a:cs typeface="Courier New" pitchFamily="34" charset="-120"/>
+              </a:rPr>
+              <a:t>OPTIMIZACIÓN DURANTE TODO EL MES</a:t>
+            </a:r>
+            <a:endParaRPr lang="en-US" sz="1500" dirty="0"/>
+          </a:p>
+        </p:txBody>
+      </p:sp>
+      <p:sp>
+        <p:nvSpPr>
+          <p:cNvPr id="12" name="Text 10"/>
+          <p:cNvSpPr/>
+          <p:nvPr/>
+        </p:nvSpPr>
+        <p:spPr>
+          <a:xfrm>
+            <a:off x="822960" y="5522976"/>
+            <a:ext cx="685800" cy="512064"/>
           </a:xfrm>
           <a:prstGeom prst="rect">
             <a:avLst/>
@@ -2572,30 +2615,30 @@
               <a:buNone/>
             </a:pPr>
             <a:r>
-              <a:rPr lang="en-US" sz="2100" dirty="0">
-                <a:solidFill>
-                  <a:srgbClr val="F2EEE9"/>
-                </a:solidFill>
-                <a:latin typeface="Calibri" pitchFamily="34" charset="0"/>
-                <a:ea typeface="Calibri" pitchFamily="34" charset="-122"/>
-                <a:cs typeface="Calibri" pitchFamily="34" charset="-120"/>
-              </a:rPr>
-              <a:t>Optimización durante todo el mes</a:t>
-            </a:r>
-            <a:endParaRPr lang="en-US" sz="2100" dirty="0"/>
-          </a:p>
-        </p:txBody>
-      </p:sp>
-      <p:sp>
-        <p:nvSpPr>
-          <p:cNvPr id="12" name="Text 10"/>
-          <p:cNvSpPr/>
-          <p:nvPr/>
-        </p:nvSpPr>
-        <p:spPr>
-          <a:xfrm>
-            <a:off x="822960" y="5504688"/>
-            <a:ext cx="658368" cy="530352"/>
+              <a:rPr lang="en-US" sz="1500" b="1" spc="100" kern="0" dirty="0">
+                <a:solidFill>
+                  <a:srgbClr val="DE27A0"/>
+                </a:solidFill>
+                <a:latin typeface="Courier New" pitchFamily="34" charset="0"/>
+                <a:ea typeface="Courier New" pitchFamily="34" charset="-122"/>
+                <a:cs typeface="Courier New" pitchFamily="34" charset="-120"/>
+              </a:rPr>
+              <a:t>05</a:t>
+            </a:r>
+            <a:endParaRPr lang="en-US" sz="1500" dirty="0"/>
+          </a:p>
+        </p:txBody>
+      </p:sp>
+      <p:sp>
+        <p:nvSpPr>
+          <p:cNvPr id="13" name="Text 11"/>
+          <p:cNvSpPr/>
+          <p:nvPr/>
+        </p:nvSpPr>
+        <p:spPr>
+          <a:xfrm>
+            <a:off x="1719072" y="5522976"/>
+            <a:ext cx="9649663" cy="512064"/>
           </a:xfrm>
           <a:prstGeom prst="rect">
             <a:avLst/>
@@ -2611,56 +2654,17 @@
               <a:buNone/>
             </a:pPr>
             <a:r>
-              <a:rPr lang="en-US" sz="1600" b="1" dirty="0">
-                <a:solidFill>
-                  <a:srgbClr val="EF5B25"/>
-                </a:solidFill>
-                <a:latin typeface="Arial" pitchFamily="34" charset="0"/>
-                <a:ea typeface="Arial" pitchFamily="34" charset="-122"/>
-                <a:cs typeface="Arial" pitchFamily="34" charset="-120"/>
-              </a:rPr>
-              <a:t>05</a:t>
-            </a:r>
-            <a:endParaRPr lang="en-US" sz="1600" dirty="0"/>
-          </a:p>
-        </p:txBody>
-      </p:sp>
-      <p:sp>
-        <p:nvSpPr>
-          <p:cNvPr id="13" name="Text 11"/>
-          <p:cNvSpPr/>
-          <p:nvPr/>
-        </p:nvSpPr>
-        <p:spPr>
-          <a:xfrm>
-            <a:off x="1664208" y="5504688"/>
-            <a:ext cx="9704527" cy="530352"/>
-          </a:xfrm>
-          <a:prstGeom prst="rect">
-            <a:avLst/>
-          </a:prstGeom>
-          <a:noFill/>
-          <a:ln/>
-        </p:spPr>
-        <p:txBody>
-          <a:bodyPr wrap="square" lIns="0" tIns="0" rIns="0" bIns="0" rtlCol="0" anchor="ctr"/>
-          <a:lstStyle/>
-          <a:p>
-            <a:pPr indent="0" marL="0">
-              <a:buNone/>
-            </a:pPr>
-            <a:r>
-              <a:rPr lang="en-US" sz="2100" dirty="0">
-                <a:solidFill>
-                  <a:srgbClr val="F2EEE9"/>
-                </a:solidFill>
-                <a:latin typeface="Calibri" pitchFamily="34" charset="0"/>
-                <a:ea typeface="Calibri" pitchFamily="34" charset="-122"/>
-                <a:cs typeface="Calibri" pitchFamily="34" charset="-120"/>
-              </a:rPr>
-              <a:t>Reporte mensual con ventas, no con likes</a:t>
-            </a:r>
-            <a:endParaRPr lang="en-US" sz="2100" dirty="0"/>
+              <a:rPr lang="en-US" sz="1500" b="1" spc="80" kern="0" dirty="0">
+                <a:solidFill>
+                  <a:srgbClr val="FFFFFF"/>
+                </a:solidFill>
+                <a:latin typeface="Courier New" pitchFamily="34" charset="0"/>
+                <a:ea typeface="Courier New" pitchFamily="34" charset="-122"/>
+                <a:cs typeface="Courier New" pitchFamily="34" charset="-120"/>
+              </a:rPr>
+              <a:t>REPORTE MENSUAL CON VENTAS, NO CON LIKES</a:t>
+            </a:r>
+            <a:endParaRPr lang="en-US" sz="1500" dirty="0"/>
           </a:p>
         </p:txBody>
       </p:sp>
@@ -2678,7 +2682,7 @@
     <p:bg>
       <p:bgPr>
         <a:solidFill>
-          <a:srgbClr val="EF5B25"/>
+          <a:srgbClr val="284E58"/>
         </a:solidFill>
       </p:bgPr>
     </p:bg>
@@ -2721,30 +2725,69 @@
               <a:buNone/>
             </a:pPr>
             <a:r>
-              <a:rPr lang="en-US" sz="1100" b="1" spc="250" kern="0" dirty="0">
-                <a:solidFill>
-                  <a:srgbClr val="140C07"/>
+              <a:rPr lang="en-US" sz="1200" b="1" spc="200" kern="0" dirty="0">
+                <a:solidFill>
+                  <a:srgbClr val="46BD7C"/>
+                </a:solidFill>
+                <a:latin typeface="Courier New" pitchFamily="34" charset="0"/>
+                <a:ea typeface="Courier New" pitchFamily="34" charset="-122"/>
+                <a:cs typeface="Courier New" pitchFamily="34" charset="-120"/>
+              </a:rPr>
+              <a:t>03  —  HONORARIO</a:t>
+            </a:r>
+            <a:endParaRPr lang="en-US" sz="1200" dirty="0"/>
+          </a:p>
+        </p:txBody>
+      </p:sp>
+      <p:sp>
+        <p:nvSpPr>
+          <p:cNvPr id="3" name="Text 1"/>
+          <p:cNvSpPr/>
+          <p:nvPr/>
+        </p:nvSpPr>
+        <p:spPr>
+          <a:xfrm>
+            <a:off x="822960" y="1600200"/>
+            <a:ext cx="8686800" cy="1600200"/>
+          </a:xfrm>
+          <a:prstGeom prst="rect">
+            <a:avLst/>
+          </a:prstGeom>
+          <a:noFill/>
+          <a:ln/>
+        </p:spPr>
+        <p:txBody>
+          <a:bodyPr wrap="square" lIns="0" tIns="0" rIns="0" bIns="0" rtlCol="0" anchor="ctr"/>
+          <a:lstStyle/>
+          <a:p>
+            <a:pPr indent="0" marL="0">
+              <a:buNone/>
+            </a:pPr>
+            <a:r>
+              <a:rPr lang="en-US" sz="9600" b="1" dirty="0">
+                <a:solidFill>
+                  <a:srgbClr val="46BD7C"/>
                 </a:solidFill>
                 <a:latin typeface="Arial" pitchFamily="34" charset="0"/>
                 <a:ea typeface="Arial" pitchFamily="34" charset="-122"/>
                 <a:cs typeface="Arial" pitchFamily="34" charset="-120"/>
               </a:rPr>
-              <a:t>03  —  HONORARIO</a:t>
-            </a:r>
-            <a:endParaRPr lang="en-US" sz="1100" dirty="0"/>
-          </a:p>
-        </p:txBody>
-      </p:sp>
-      <p:sp>
-        <p:nvSpPr>
-          <p:cNvPr id="3" name="Text 1"/>
-          <p:cNvSpPr/>
-          <p:nvPr/>
-        </p:nvSpPr>
-        <p:spPr>
-          <a:xfrm>
-            <a:off x="822960" y="1600200"/>
-            <a:ext cx="8686800" cy="1600200"/>
+              <a:t>$350.000</a:t>
+            </a:r>
+            <a:endParaRPr lang="en-US" sz="9600" dirty="0"/>
+          </a:p>
+        </p:txBody>
+      </p:sp>
+      <p:sp>
+        <p:nvSpPr>
+          <p:cNvPr id="4" name="Text 2"/>
+          <p:cNvSpPr/>
+          <p:nvPr/>
+        </p:nvSpPr>
+        <p:spPr>
+          <a:xfrm>
+            <a:off x="822960" y="3364992"/>
+            <a:ext cx="7315200" cy="384048"/>
           </a:xfrm>
           <a:prstGeom prst="rect">
             <a:avLst/>
@@ -2760,56 +2803,17 @@
               <a:buNone/>
             </a:pPr>
             <a:r>
-              <a:rPr lang="en-US" sz="9600" b="1" dirty="0">
-                <a:solidFill>
-                  <a:srgbClr val="140C07"/>
-                </a:solidFill>
-                <a:latin typeface="Arial" pitchFamily="34" charset="0"/>
-                <a:ea typeface="Arial" pitchFamily="34" charset="-122"/>
-                <a:cs typeface="Arial" pitchFamily="34" charset="-120"/>
-              </a:rPr>
-              <a:t>$350.000</a:t>
-            </a:r>
-            <a:endParaRPr lang="en-US" sz="9600" dirty="0"/>
-          </a:p>
-        </p:txBody>
-      </p:sp>
-      <p:sp>
-        <p:nvSpPr>
-          <p:cNvPr id="4" name="Text 2"/>
-          <p:cNvSpPr/>
-          <p:nvPr/>
-        </p:nvSpPr>
-        <p:spPr>
-          <a:xfrm>
-            <a:off x="822960" y="3310128"/>
-            <a:ext cx="7315200" cy="457200"/>
-          </a:xfrm>
-          <a:prstGeom prst="rect">
-            <a:avLst/>
-          </a:prstGeom>
-          <a:noFill/>
-          <a:ln/>
-        </p:spPr>
-        <p:txBody>
-          <a:bodyPr wrap="square" lIns="0" tIns="0" rIns="0" bIns="0" rtlCol="0" anchor="ctr"/>
-          <a:lstStyle/>
-          <a:p>
-            <a:pPr indent="0" marL="0">
-              <a:buNone/>
-            </a:pPr>
-            <a:r>
-              <a:rPr lang="en-US" sz="2400" dirty="0">
-                <a:solidFill>
-                  <a:srgbClr val="140C07"/>
-                </a:solidFill>
-                <a:latin typeface="Calibri" pitchFamily="34" charset="0"/>
-                <a:ea typeface="Calibri" pitchFamily="34" charset="-122"/>
-                <a:cs typeface="Calibri" pitchFamily="34" charset="-120"/>
-              </a:rPr>
-              <a:t>líquidos al mes</a:t>
-            </a:r>
-            <a:endParaRPr lang="en-US" sz="2400" dirty="0"/>
+              <a:rPr lang="en-US" sz="1800" b="1" spc="300" kern="0" dirty="0">
+                <a:solidFill>
+                  <a:srgbClr val="FFFFFF"/>
+                </a:solidFill>
+                <a:latin typeface="Courier New" pitchFamily="34" charset="0"/>
+                <a:ea typeface="Courier New" pitchFamily="34" charset="-122"/>
+                <a:cs typeface="Courier New" pitchFamily="34" charset="-120"/>
+              </a:rPr>
+              <a:t>LÍQUIDOS AL MES</a:t>
+            </a:r>
+            <a:endParaRPr lang="en-US" sz="1800" dirty="0"/>
           </a:p>
         </p:txBody>
       </p:sp>
@@ -2838,17 +2842,17 @@
               <a:buNone/>
             </a:pPr>
             <a:r>
-              <a:rPr lang="en-US" sz="1050" b="1" spc="200" kern="0" dirty="0">
-                <a:solidFill>
-                  <a:srgbClr val="140C07"/>
-                </a:solidFill>
-                <a:latin typeface="Arial" pitchFamily="34" charset="0"/>
-                <a:ea typeface="Arial" pitchFamily="34" charset="-122"/>
-                <a:cs typeface="Arial" pitchFamily="34" charset="-120"/>
+              <a:rPr lang="en-US" sz="1100" b="1" spc="200" kern="0" dirty="0">
+                <a:solidFill>
+                  <a:srgbClr val="46BD7C"/>
+                </a:solidFill>
+                <a:latin typeface="Courier New" pitchFamily="34" charset="0"/>
+                <a:ea typeface="Courier New" pitchFamily="34" charset="-122"/>
+                <a:cs typeface="Courier New" pitchFamily="34" charset="-120"/>
               </a:rPr>
               <a:t>LA PAUTA VA APARTE</a:t>
             </a:r>
-            <a:endParaRPr lang="en-US" sz="1050" dirty="0"/>
+            <a:endParaRPr lang="en-US" sz="1100" dirty="0"/>
           </a:p>
         </p:txBody>
       </p:sp>
@@ -2860,8 +2864,8 @@
         </p:nvSpPr>
         <p:spPr>
           <a:xfrm>
-            <a:off x="822960" y="5010912"/>
-            <a:ext cx="4846320" cy="1234440"/>
+            <a:off x="822960" y="5029200"/>
+            <a:ext cx="4846320" cy="1280160"/>
           </a:xfrm>
           <a:prstGeom prst="rect">
             <a:avLst/>
@@ -2875,22 +2879,22 @@
           <a:p>
             <a:pPr indent="0" marL="0">
               <a:lnSpc>
-                <a:spcPct val="120000"/>
+                <a:spcPct val="135000"/>
               </a:lnSpc>
               <a:buNone/>
             </a:pPr>
             <a:r>
-              <a:rPr lang="en-US" sz="1600" b="1" dirty="0">
-                <a:solidFill>
-                  <a:srgbClr val="140C07"/>
-                </a:solidFill>
-                <a:latin typeface="Arial" pitchFamily="34" charset="0"/>
-                <a:ea typeface="Arial" pitchFamily="34" charset="-122"/>
-                <a:cs typeface="Arial" pitchFamily="34" charset="-120"/>
-              </a:rPr>
-              <a:t>Entre $200.000 y $450.000 al mes según la fase, a nombre de PobreVermut.</a:t>
-            </a:r>
-            <a:endParaRPr lang="en-US" sz="1600" dirty="0"/>
+              <a:rPr lang="en-US" sz="1150" b="1" spc="50" kern="0" dirty="0">
+                <a:solidFill>
+                  <a:srgbClr val="FFFFFF"/>
+                </a:solidFill>
+                <a:latin typeface="Courier New" pitchFamily="34" charset="0"/>
+                <a:ea typeface="Courier New" pitchFamily="34" charset="-122"/>
+                <a:cs typeface="Courier New" pitchFamily="34" charset="-120"/>
+              </a:rPr>
+              <a:t>ENTRE $200.000 Y $450.000 AL MES SEGÚN LA FASE, A NOMBRE DE POBREVERMUT.</a:t>
+            </a:r>
+            <a:endParaRPr lang="en-US" sz="1150" dirty="0"/>
           </a:p>
         </p:txBody>
       </p:sp>
@@ -2919,17 +2923,17 @@
               <a:buNone/>
             </a:pPr>
             <a:r>
-              <a:rPr lang="en-US" sz="1050" b="1" spc="200" kern="0" dirty="0">
-                <a:solidFill>
-                  <a:srgbClr val="140C07"/>
-                </a:solidFill>
-                <a:latin typeface="Arial" pitchFamily="34" charset="0"/>
-                <a:ea typeface="Arial" pitchFamily="34" charset="-122"/>
-                <a:cs typeface="Arial" pitchFamily="34" charset="-120"/>
+              <a:rPr lang="en-US" sz="1100" b="1" spc="200" kern="0" dirty="0">
+                <a:solidFill>
+                  <a:srgbClr val="46BD7C"/>
+                </a:solidFill>
+                <a:latin typeface="Courier New" pitchFamily="34" charset="0"/>
+                <a:ea typeface="Courier New" pitchFamily="34" charset="-122"/>
+                <a:cs typeface="Courier New" pitchFamily="34" charset="-120"/>
               </a:rPr>
               <a:t>UN PRIMER CICLO DE TRES MESES</a:t>
             </a:r>
-            <a:endParaRPr lang="en-US" sz="1050" dirty="0"/>
+            <a:endParaRPr lang="en-US" sz="1100" dirty="0"/>
           </a:p>
         </p:txBody>
       </p:sp>
@@ -2941,8 +2945,8 @@
         </p:nvSpPr>
         <p:spPr>
           <a:xfrm>
-            <a:off x="6245352" y="5010912"/>
-            <a:ext cx="4846320" cy="1234440"/>
+            <a:off x="6245352" y="5029200"/>
+            <a:ext cx="4846320" cy="1280160"/>
           </a:xfrm>
           <a:prstGeom prst="rect">
             <a:avLst/>
@@ -2956,22 +2960,22 @@
           <a:p>
             <a:pPr indent="0" marL="0">
               <a:lnSpc>
-                <a:spcPct val="120000"/>
+                <a:spcPct val="135000"/>
               </a:lnSpc>
               <a:buNone/>
             </a:pPr>
             <a:r>
-              <a:rPr lang="en-US" sz="1600" b="1" dirty="0">
-                <a:solidFill>
-                  <a:srgbClr val="140C07"/>
-                </a:solidFill>
-                <a:latin typeface="Arial" pitchFamily="34" charset="0"/>
-                <a:ea typeface="Arial" pitchFamily="34" charset="-122"/>
-                <a:cs typeface="Arial" pitchFamily="34" charset="-120"/>
-              </a:rPr>
-              <a:t>Partimos con tres meses de trabajo. Al cierre revisamos juntos los resultados y definimos cómo seguir.</a:t>
-            </a:r>
-            <a:endParaRPr lang="en-US" sz="1600" dirty="0"/>
+              <a:rPr lang="en-US" sz="1150" b="1" spc="50" kern="0" dirty="0">
+                <a:solidFill>
+                  <a:srgbClr val="FFFFFF"/>
+                </a:solidFill>
+                <a:latin typeface="Courier New" pitchFamily="34" charset="0"/>
+                <a:ea typeface="Courier New" pitchFamily="34" charset="-122"/>
+                <a:cs typeface="Courier New" pitchFamily="34" charset="-120"/>
+              </a:rPr>
+              <a:t>PARTIMOS CON TRES MESES DE TRABAJO. AL CIERRE REVISAMOS JUNTOS LOS RESULTADOS Y DEFINIMOS CÓMO SEGUIR.</a:t>
+            </a:r>
+            <a:endParaRPr lang="en-US" sz="1150" dirty="0"/>
           </a:p>
         </p:txBody>
       </p:sp>
@@ -2989,7 +2993,7 @@
     <p:bg>
       <p:bgPr>
         <a:solidFill>
-          <a:srgbClr val="0F0E0D"/>
+          <a:srgbClr val="3A1842"/>
         </a:solidFill>
       </p:bgPr>
     </p:bg>
@@ -3007,36 +3011,40 @@
           <a:chExt cx="0" cy="0"/>
         </a:xfrm>
       </p:grpSpPr>
-      <p:sp>
-        <p:nvSpPr>
-          <p:cNvPr id="2" name="Shape 0"/>
-          <p:cNvSpPr/>
-          <p:nvPr/>
-        </p:nvSpPr>
-        <p:spPr>
-          <a:xfrm>
-            <a:off x="5687568" y="1691640"/>
-            <a:ext cx="822960" cy="822960"/>
-          </a:xfrm>
-          <a:prstGeom prst="ellipse">
-            <a:avLst/>
-          </a:prstGeom>
-          <a:solidFill>
-            <a:srgbClr val="EF5B25"/>
-          </a:solidFill>
-          <a:ln/>
-        </p:spPr>
-      </p:sp>
-      <p:sp>
-        <p:nvSpPr>
-          <p:cNvPr id="3" name="Text 1"/>
-          <p:cNvSpPr/>
-          <p:nvPr/>
-        </p:nvSpPr>
-        <p:spPr>
-          <a:xfrm>
-            <a:off x="1371600" y="2999232"/>
-            <a:ext cx="9445752" cy="1005840"/>
+      <p:pic>
+        <p:nvPicPr>
+          <p:cNvPr id="2" name="Image 0" descr="/tmp/claude-0/-home-user-Gmb-Aagent/415d07b8-2eab-51b2-81d2-2f92b3b46afc/scratchpad/marca/tagline-blanco.png">    </p:cNvPr>
+          <p:cNvPicPr>
+            <a:picLocks noChangeAspect="1"/>
+          </p:cNvPicPr>
+          <p:nvPr/>
+        </p:nvPicPr>
+        <p:blipFill>
+          <a:blip r:embed="rId1"/>
+          <a:stretch>
+            <a:fillRect/>
+          </a:stretch>
+        </p:blipFill>
+        <p:spPr>
+          <a:xfrm>
+            <a:off x="5230368" y="1051560"/>
+            <a:ext cx="1728216" cy="1883664"/>
+          </a:xfrm>
+          <a:prstGeom prst="rect">
+            <a:avLst/>
+          </a:prstGeom>
+        </p:spPr>
+      </p:pic>
+      <p:sp>
+        <p:nvSpPr>
+          <p:cNvPr id="3" name="Text 0"/>
+          <p:cNvSpPr/>
+          <p:nvPr/>
+        </p:nvSpPr>
+        <p:spPr>
+          <a:xfrm>
+            <a:off x="1371600" y="3456432"/>
+            <a:ext cx="9445752" cy="868680"/>
           </a:xfrm>
           <a:prstGeom prst="rect">
             <a:avLst/>
@@ -3052,44 +3060,44 @@
               <a:buNone/>
             </a:pPr>
             <a:r>
-              <a:rPr lang="en-US" sz="5200" b="1" dirty="0">
-                <a:solidFill>
-                  <a:srgbClr val="F2EEE9"/>
+              <a:rPr lang="en-US" sz="4600" b="1" dirty="0">
+                <a:solidFill>
+                  <a:srgbClr val="FFFFFF"/>
                 </a:solidFill>
                 <a:latin typeface="Arial" pitchFamily="34" charset="0"/>
                 <a:ea typeface="Arial" pitchFamily="34" charset="-122"/>
                 <a:cs typeface="Arial" pitchFamily="34" charset="-120"/>
               </a:rPr>
-              <a:t>Trabajemos </a:t>
+              <a:t>TRABAJEMOS </a:t>
             </a:r>
             <a:pPr algn="ctr" indent="0" marL="0">
               <a:buNone/>
             </a:pPr>
             <a:r>
-              <a:rPr lang="en-US" sz="5200" b="1" dirty="0">
-                <a:solidFill>
-                  <a:srgbClr val="EF5B25"/>
+              <a:rPr lang="en-US" sz="4600" b="1" dirty="0">
+                <a:solidFill>
+                  <a:srgbClr val="DE27A0"/>
                 </a:solidFill>
                 <a:latin typeface="Arial" pitchFamily="34" charset="0"/>
                 <a:ea typeface="Arial" pitchFamily="34" charset="-122"/>
                 <a:cs typeface="Arial" pitchFamily="34" charset="-120"/>
               </a:rPr>
-              <a:t>juntos.</a:t>
-            </a:r>
-            <a:endParaRPr lang="en-US" sz="5200" dirty="0"/>
-          </a:p>
-        </p:txBody>
-      </p:sp>
-      <p:sp>
-        <p:nvSpPr>
-          <p:cNvPr id="4" name="Text 2"/>
-          <p:cNvSpPr/>
-          <p:nvPr/>
-        </p:nvSpPr>
-        <p:spPr>
-          <a:xfrm>
-            <a:off x="1371600" y="4709160"/>
-            <a:ext cx="9445752" cy="329184"/>
+              <a:t>JUNTOS</a:t>
+            </a:r>
+            <a:endParaRPr lang="en-US" sz="4600" dirty="0"/>
+          </a:p>
+        </p:txBody>
+      </p:sp>
+      <p:sp>
+        <p:nvSpPr>
+          <p:cNvPr id="4" name="Text 1"/>
+          <p:cNvSpPr/>
+          <p:nvPr/>
+        </p:nvSpPr>
+        <p:spPr>
+          <a:xfrm>
+            <a:off x="1371600" y="4828032"/>
+            <a:ext cx="9445752" cy="292608"/>
           </a:xfrm>
           <a:prstGeom prst="rect">
             <a:avLst/>
@@ -3105,30 +3113,30 @@
               <a:buNone/>
             </a:pPr>
             <a:r>
-              <a:rPr lang="en-US" sz="1600" b="1" dirty="0">
-                <a:solidFill>
-                  <a:srgbClr val="F2EEE9"/>
-                </a:solidFill>
-                <a:latin typeface="Arial" pitchFamily="34" charset="0"/>
-                <a:ea typeface="Arial" pitchFamily="34" charset="-122"/>
-                <a:cs typeface="Arial" pitchFamily="34" charset="-120"/>
-              </a:rPr>
-              <a:t>Nicolás</a:t>
-            </a:r>
-            <a:endParaRPr lang="en-US" sz="1600" dirty="0"/>
-          </a:p>
-        </p:txBody>
-      </p:sp>
-      <p:sp>
-        <p:nvSpPr>
-          <p:cNvPr id="5" name="Text 3"/>
-          <p:cNvSpPr/>
-          <p:nvPr/>
-        </p:nvSpPr>
-        <p:spPr>
-          <a:xfrm>
-            <a:off x="1371600" y="5065776"/>
-            <a:ext cx="9445752" cy="329184"/>
+              <a:rPr lang="en-US" sz="1300" b="1" spc="300" kern="0" dirty="0">
+                <a:solidFill>
+                  <a:srgbClr val="FFFFFF"/>
+                </a:solidFill>
+                <a:latin typeface="Courier New" pitchFamily="34" charset="0"/>
+                <a:ea typeface="Courier New" pitchFamily="34" charset="-122"/>
+                <a:cs typeface="Courier New" pitchFamily="34" charset="-120"/>
+              </a:rPr>
+              <a:t>NICOLÁS</a:t>
+            </a:r>
+            <a:endParaRPr lang="en-US" sz="1300" dirty="0"/>
+          </a:p>
+        </p:txBody>
+      </p:sp>
+      <p:sp>
+        <p:nvSpPr>
+          <p:cNvPr id="5" name="Text 2"/>
+          <p:cNvSpPr/>
+          <p:nvPr/>
+        </p:nvSpPr>
+        <p:spPr>
+          <a:xfrm>
+            <a:off x="1371600" y="5193792"/>
+            <a:ext cx="9445752" cy="292608"/>
           </a:xfrm>
           <a:prstGeom prst="rect">
             <a:avLst/>
@@ -3144,17 +3152,17 @@
               <a:buNone/>
             </a:pPr>
             <a:r>
-              <a:rPr lang="en-US" sz="1500" dirty="0">
-                <a:solidFill>
-                  <a:srgbClr val="8A807A"/>
-                </a:solidFill>
-                <a:latin typeface="Calibri" pitchFamily="34" charset="0"/>
-                <a:ea typeface="Calibri" pitchFamily="34" charset="-122"/>
-                <a:cs typeface="Calibri" pitchFamily="34" charset="-120"/>
-              </a:rPr>
-              <a:t>nicolas@sherpasstudio.cl  ·  +56 9 3125 6539</a:t>
-            </a:r>
-            <a:endParaRPr lang="en-US" sz="1500" dirty="0"/>
+              <a:rPr lang="en-US" sz="1100" b="1" spc="100" kern="0" dirty="0">
+                <a:solidFill>
+                  <a:srgbClr val="BFA3C8"/>
+                </a:solidFill>
+                <a:latin typeface="Courier New" pitchFamily="34" charset="0"/>
+                <a:ea typeface="Courier New" pitchFamily="34" charset="-122"/>
+                <a:cs typeface="Courier New" pitchFamily="34" charset="-120"/>
+              </a:rPr>
+              <a:t>NICOLAS@SHERPASSTUDIO.CL  ·  +56 9 3125 6539</a:t>
+            </a:r>
+            <a:endParaRPr lang="en-US" sz="1100" dirty="0"/>
           </a:p>
         </p:txBody>
       </p:sp>

</xml_diff>

<commit_message>
Saca el vaso de la portada de la propuesta
La portada queda solo con tipografía. Se elimina también el activo del vaso,
que ya no se usa en ningún slide.

Co-Authored-By: Claude Opus 5 <noreply@anthropic.com>
Claude-Session: https://claude.ai/code/session_01TbbPRaX9MW6Lcxus2ycV3h
</commit_message>
<xml_diff>
--- a/propuestas/pobrevermut/PobreVermut - Propuesta Campanas 2026.pptx
+++ b/propuestas/pobrevermut/PobreVermut - Propuesta Campanas 2026.pptx
@@ -1231,33 +1231,9 @@
           <a:chExt cx="0" cy="0"/>
         </a:xfrm>
       </p:grpSpPr>
-      <p:pic>
-        <p:nvPicPr>
-          <p:cNvPr id="2" name="Image 0" descr="/tmp/claude-0/-home-user-Gmb-Aagent/415d07b8-2eab-51b2-81d2-2f92b3b46afc/scratchpad/marca/vaso-magenta.png">    </p:cNvPr>
-          <p:cNvPicPr>
-            <a:picLocks noChangeAspect="1"/>
-          </p:cNvPicPr>
-          <p:nvPr/>
-        </p:nvPicPr>
-        <p:blipFill>
-          <a:blip r:embed="rId1"/>
-          <a:stretch>
-            <a:fillRect/>
-          </a:stretch>
-        </p:blipFill>
-        <p:spPr>
-          <a:xfrm>
-            <a:off x="9555480" y="1847088"/>
-            <a:ext cx="1792224" cy="2843784"/>
-          </a:xfrm>
-          <a:prstGeom prst="rect">
-            <a:avLst/>
-          </a:prstGeom>
-        </p:spPr>
-      </p:pic>
-      <p:sp>
-        <p:nvSpPr>
-          <p:cNvPr id="3" name="Text 0"/>
+      <p:sp>
+        <p:nvSpPr>
+          <p:cNvPr id="2" name="Text 0"/>
           <p:cNvSpPr/>
           <p:nvPr/>
         </p:nvSpPr>
@@ -1296,7 +1272,7 @@
       </p:sp>
       <p:sp>
         <p:nvSpPr>
-          <p:cNvPr id="4" name="Text 1"/>
+          <p:cNvPr id="3" name="Text 1"/>
           <p:cNvSpPr/>
           <p:nvPr/>
         </p:nvSpPr>
@@ -1358,7 +1334,7 @@
       </p:sp>
       <p:sp>
         <p:nvSpPr>
-          <p:cNvPr id="5" name="Text 2"/>
+          <p:cNvPr id="4" name="Text 2"/>
           <p:cNvSpPr/>
           <p:nvPr/>
         </p:nvSpPr>
@@ -1397,7 +1373,7 @@
       </p:sp>
       <p:sp>
         <p:nvSpPr>
-          <p:cNvPr id="6" name="Text 3"/>
+          <p:cNvPr id="5" name="Text 3"/>
           <p:cNvSpPr/>
           <p:nvPr/>
         </p:nvSpPr>
@@ -1436,7 +1412,7 @@
       </p:sp>
       <p:sp>
         <p:nvSpPr>
-          <p:cNvPr id="7" name="Text 4"/>
+          <p:cNvPr id="6" name="Text 4"/>
           <p:cNvSpPr/>
           <p:nvPr/>
         </p:nvSpPr>

</xml_diff>